<commit_message>
Add exact ACRS formulas and ToolBench / AGMARKNET pipeline walkthroughs.
SATR, APRR, MNCD, and FCNP equations as implemented, plus two full
SATR→APRR→MNCD→FCNP traces on a ToolBench-schema soil tool and live
data.gov.in mandi prices. FET slides 08f–08h; laboratory /walkthrough.
</commit_message>
<xml_diff>
--- a/docs/slides/ACRS_PhD_Proposal_JenishaT_24ETRP720001.pptx
+++ b/docs/slides/ACRS_PhD_Proposal_JenishaT_24ETRP720001.pptx
@@ -31,6 +31,9 @@
     <p:sldId id="279" r:id="rId30"/>
     <p:sldId id="280" r:id="rId31"/>
     <p:sldId id="281" r:id="rId32"/>
+    <p:sldId id="282" r:id="rId33"/>
+    <p:sldId id="283" r:id="rId34"/>
+    <p:sldId id="284" r:id="rId35"/>
   </p:sldIdLst>
   <p:sldSz cx="12191695" cy="6858000" type="screen4x3"/>
   <p:notesSz cx="6858000" cy="9144000"/>
@@ -3877,7 +3880,7 @@
           <a:lstStyle/>
           <a:p>
             <a:pPr algn="l"/>
-            <a:fld id="{b98f9638-04df-4c72-9c92-606d10a7ef95}" type="datetime3">
+            <a:fld id="{83e579be-63f4-4788-a6c2-180dd5d096fe}" type="datetime3">
               <a:rPr lang="en-GB" sz="1000" dirty="0">
                 <a:solidFill>
                   <a:srgbClr val="C4A35A"/>
@@ -3911,7 +3914,7 @@
           <a:lstStyle/>
           <a:p>
             <a:pPr algn="r"/>
-            <a:fld id="{a85ef5c4-7dfc-429b-bbf1-dbb2695ad106}" type="slidenum">
+            <a:fld id="{ed52e502-5a0f-4e2b-9b59-06022553a770}" type="slidenum">
               <a:rPr lang="en-GB" sz="1000" dirty="0">
                 <a:solidFill>
                   <a:srgbClr val="C4A35A"/>
@@ -3927,7 +3930,7 @@
                 </a:solidFill>
                 <a:latin typeface="Calibri"/>
               </a:rPr>
-              <a:t> / 26</a:t>
+              <a:t> / 29</a:t>
             </a:r>
             <a:endParaRPr lang="en-GB" sz="1000"/>
           </a:p>
@@ -4722,7 +4725,7 @@
           <a:lstStyle/>
           <a:p>
             <a:pPr algn="l"/>
-            <a:fld id="{6c7b8693-73b9-41f7-9ad5-234c74dd9c45}" type="datetime3">
+            <a:fld id="{f90767aa-7782-491b-8bdb-8b478202b1cd}" type="datetime3">
               <a:rPr lang="en-GB" sz="1000" dirty="0">
                 <a:solidFill>
                   <a:srgbClr val="C4A35A"/>
@@ -4756,7 +4759,7 @@
           <a:lstStyle/>
           <a:p>
             <a:pPr algn="r"/>
-            <a:fld id="{c50ced96-0f47-4875-a185-a887ef4b13ed}" type="slidenum">
+            <a:fld id="{910170b1-6529-4f59-b33b-ffd83907e1cb}" type="slidenum">
               <a:rPr lang="en-GB" sz="1000" dirty="0">
                 <a:solidFill>
                   <a:srgbClr val="C4A35A"/>
@@ -4772,7 +4775,7 @@
                 </a:solidFill>
                 <a:latin typeface="Calibri"/>
               </a:rPr>
-              <a:t> / 26</a:t>
+              <a:t> / 29</a:t>
             </a:r>
             <a:endParaRPr lang="en-GB" sz="1000"/>
           </a:p>
@@ -5779,7 +5782,7 @@
           <a:lstStyle/>
           <a:p>
             <a:pPr algn="l"/>
-            <a:fld id="{47d4c20c-946e-41da-ab15-f1789a7c1123}" type="datetime3">
+            <a:fld id="{d884dfe5-9119-4e49-8dc6-e43f96439049}" type="datetime3">
               <a:rPr lang="en-GB" sz="1000" dirty="0">
                 <a:solidFill>
                   <a:srgbClr val="C4A35A"/>
@@ -5813,7 +5816,7 @@
           <a:lstStyle/>
           <a:p>
             <a:pPr algn="r"/>
-            <a:fld id="{9a8edc2e-45ac-4561-b3ee-f91a3ec3ce8b}" type="slidenum">
+            <a:fld id="{650cf51f-9584-4990-8991-1c3080f07a89}" type="slidenum">
               <a:rPr lang="en-GB" sz="1000" dirty="0">
                 <a:solidFill>
                   <a:srgbClr val="C4A35A"/>
@@ -5829,7 +5832,7 @@
                 </a:solidFill>
                 <a:latin typeface="Calibri"/>
               </a:rPr>
-              <a:t> / 26</a:t>
+              <a:t> / 29</a:t>
             </a:r>
             <a:endParaRPr lang="en-GB" sz="1000"/>
           </a:p>
@@ -6728,7 +6731,7 @@
           <a:lstStyle/>
           <a:p>
             <a:pPr algn="l"/>
-            <a:fld id="{f26a099f-d2d6-4df0-b459-b87f86e58f87}" type="datetime3">
+            <a:fld id="{15782857-843a-4951-90b8-d59b027ae312}" type="datetime3">
               <a:rPr lang="en-GB" sz="1000" dirty="0">
                 <a:solidFill>
                   <a:srgbClr val="C4A35A"/>
@@ -6762,7 +6765,7 @@
           <a:lstStyle/>
           <a:p>
             <a:pPr algn="r"/>
-            <a:fld id="{5861caa7-531b-4a35-8397-7d7e0641079f}" type="slidenum">
+            <a:fld id="{e5fee357-7c02-4d79-81b7-b356f9faef1c}" type="slidenum">
               <a:rPr lang="en-GB" sz="1000" dirty="0">
                 <a:solidFill>
                   <a:srgbClr val="C4A35A"/>
@@ -6778,7 +6781,7 @@
                 </a:solidFill>
                 <a:latin typeface="Calibri"/>
               </a:rPr>
-              <a:t> / 26</a:t>
+              <a:t> / 29</a:t>
             </a:r>
             <a:endParaRPr lang="en-GB" sz="1000"/>
           </a:p>
@@ -7623,7 +7626,7 @@
           <a:lstStyle/>
           <a:p>
             <a:pPr algn="l"/>
-            <a:fld id="{c45c5187-474d-4c51-ab7b-081890602298}" type="datetime3">
+            <a:fld id="{b1a7769a-410d-4a4b-9deb-ecb129e0d8ea}" type="datetime3">
               <a:rPr lang="en-GB" sz="1000" dirty="0">
                 <a:solidFill>
                   <a:srgbClr val="C4A35A"/>
@@ -7657,7 +7660,7 @@
           <a:lstStyle/>
           <a:p>
             <a:pPr algn="r"/>
-            <a:fld id="{684cac2c-bc18-4a8b-803b-6c0fab206b16}" type="slidenum">
+            <a:fld id="{297e6af9-f449-4c77-b139-178b9ed3a1bf}" type="slidenum">
               <a:rPr lang="en-GB" sz="1000" dirty="0">
                 <a:solidFill>
                   <a:srgbClr val="C4A35A"/>
@@ -7673,7 +7676,7 @@
                 </a:solidFill>
                 <a:latin typeface="Calibri"/>
               </a:rPr>
-              <a:t> / 26</a:t>
+              <a:t> / 29</a:t>
             </a:r>
             <a:endParaRPr lang="en-GB" sz="1000"/>
           </a:p>
@@ -8572,7 +8575,7 @@
           <a:lstStyle/>
           <a:p>
             <a:pPr algn="l"/>
-            <a:fld id="{915faa91-7932-4d71-8c50-263f18a71d86}" type="datetime3">
+            <a:fld id="{1f2103da-f21b-42fa-827a-3ebd3efa9e9f}" type="datetime3">
               <a:rPr lang="en-GB" sz="1000" dirty="0">
                 <a:solidFill>
                   <a:srgbClr val="C4A35A"/>
@@ -8606,7 +8609,7 @@
           <a:lstStyle/>
           <a:p>
             <a:pPr algn="r"/>
-            <a:fld id="{831f242d-129f-47ab-819a-2ff0030a1982}" type="slidenum">
+            <a:fld id="{c2bdb072-023c-429f-b7e4-33acfbfc82f7}" type="slidenum">
               <a:rPr lang="en-GB" sz="1000" dirty="0">
                 <a:solidFill>
                   <a:srgbClr val="C4A35A"/>
@@ -8622,7 +8625,7 @@
                 </a:solidFill>
                 <a:latin typeface="Calibri"/>
               </a:rPr>
-              <a:t> / 26</a:t>
+              <a:t> / 29</a:t>
             </a:r>
             <a:endParaRPr lang="en-GB" sz="1000"/>
           </a:p>
@@ -9145,7 +9148,7 @@
           <a:lstStyle/>
           <a:p>
             <a:pPr algn="l"/>
-            <a:fld id="{5ff438f2-5e87-4d2e-b759-dce808b5a121}" type="datetime3">
+            <a:fld id="{8291e4b9-ddf5-472d-845b-23f69fa140b0}" type="datetime3">
               <a:rPr lang="en-GB" sz="1000" dirty="0">
                 <a:solidFill>
                   <a:srgbClr val="C4A35A"/>
@@ -9179,7 +9182,7 @@
           <a:lstStyle/>
           <a:p>
             <a:pPr algn="r"/>
-            <a:fld id="{ba7e406a-6cea-4061-b670-59c1f6fd3f94}" type="slidenum">
+            <a:fld id="{d1c11a1d-86c3-4325-bfca-6eb1736a58e6}" type="slidenum">
               <a:rPr lang="en-GB" sz="1000" dirty="0">
                 <a:solidFill>
                   <a:srgbClr val="C4A35A"/>
@@ -9195,7 +9198,7 @@
                 </a:solidFill>
                 <a:latin typeface="Calibri"/>
               </a:rPr>
-              <a:t> / 26</a:t>
+              <a:t> / 29</a:t>
             </a:r>
             <a:endParaRPr lang="en-GB" sz="1000"/>
           </a:p>
@@ -9728,6 +9731,24 @@
                 </a:solidFill>
                 <a:latin typeface="Calibri"/>
               </a:rPr>
+              <a:t>Implementation. The four modules are the functions in satr.ts, aprr.ts, mncd.ts, fcnp.ts — formulas on the next slides, full traces on /walkthrough.</a:t>
+            </a:r>
+          </a:p>
+          <a:p>
+            <a:pPr>
+              <a:spcAft>
+                <a:spcPts val="600"/>
+              </a:spcAft>
+              <a:buFont typeface="Arial"/>
+              <a:buChar char="•"/>
+            </a:pPr>
+            <a:r>
+              <a:rPr sz="1300">
+                <a:solidFill>
+                  <a:srgbClr val="1A1214"/>
+                </a:solidFill>
+                <a:latin typeface="Calibri"/>
+              </a:rPr>
               <a:t>What will not appear in this proposal. Promised retrieval scores, latency targets, consensus percentages, or token-reduction ratios.</a:t>
             </a:r>
           </a:p>
@@ -10113,7 +10134,7 @@
           <a:lstStyle/>
           <a:p>
             <a:pPr algn="l"/>
-            <a:fld id="{74304ce5-3c27-4c7f-b72e-fadf4c76f9fa}" type="datetime3">
+            <a:fld id="{0f034aa5-9251-46b6-8b37-bbf5bed02ddb}" type="datetime3">
               <a:rPr lang="en-GB" sz="1000" dirty="0">
                 <a:solidFill>
                   <a:srgbClr val="C4A35A"/>
@@ -10147,7 +10168,7 @@
           <a:lstStyle/>
           <a:p>
             <a:pPr algn="r"/>
-            <a:fld id="{2c6e9561-14e6-4a26-b041-c283711a2acd}" type="slidenum">
+            <a:fld id="{e31d84c6-9c34-4ae3-b059-414c1b348969}" type="slidenum">
               <a:rPr lang="en-GB" sz="1000" dirty="0">
                 <a:solidFill>
                   <a:srgbClr val="C4A35A"/>
@@ -10163,7 +10184,7 @@
                 </a:solidFill>
                 <a:latin typeface="Calibri"/>
               </a:rPr>
-              <a:t> / 26</a:t>
+              <a:t> / 29</a:t>
             </a:r>
             <a:endParaRPr lang="en-GB" sz="1000"/>
           </a:p>
@@ -10722,7 +10743,7 @@
           <a:lstStyle/>
           <a:p>
             <a:pPr algn="l"/>
-            <a:fld id="{49381238-ea32-4edf-86ba-fcfa69984ff3}" type="datetime3">
+            <a:fld id="{6d122bc5-fac9-41f0-9724-ae9723b8bb30}" type="datetime3">
               <a:rPr lang="en-GB" sz="1000" dirty="0">
                 <a:solidFill>
                   <a:srgbClr val="C4A35A"/>
@@ -10756,7 +10777,7 @@
           <a:lstStyle/>
           <a:p>
             <a:pPr algn="r"/>
-            <a:fld id="{9d757bba-e520-4b7f-998d-215bd437c54e}" type="slidenum">
+            <a:fld id="{6b437917-906d-455a-b1e3-a6a6f0c24ee8}" type="slidenum">
               <a:rPr lang="en-GB" sz="1000" dirty="0">
                 <a:solidFill>
                   <a:srgbClr val="C4A35A"/>
@@ -10772,7 +10793,7 @@
                 </a:solidFill>
                 <a:latin typeface="Calibri"/>
               </a:rPr>
-              <a:t> / 26</a:t>
+              <a:t> / 29</a:t>
             </a:r>
             <a:endParaRPr lang="en-GB" sz="1000"/>
           </a:p>
@@ -11331,7 +11352,7 @@
           <a:lstStyle/>
           <a:p>
             <a:pPr algn="l"/>
-            <a:fld id="{9dec8c96-b996-4ecf-82e9-35843929c280}" type="datetime3">
+            <a:fld id="{6d2a41ad-8a07-4bb7-b393-8dae1b791f82}" type="datetime3">
               <a:rPr lang="en-GB" sz="1000" dirty="0">
                 <a:solidFill>
                   <a:srgbClr val="C4A35A"/>
@@ -11365,7 +11386,7 @@
           <a:lstStyle/>
           <a:p>
             <a:pPr algn="r"/>
-            <a:fld id="{543e504a-503c-4bbd-959a-4cec825e8d01}" type="slidenum">
+            <a:fld id="{3e929ac0-3c05-466c-ba11-6e24f0e123e5}" type="slidenum">
               <a:rPr lang="en-GB" sz="1000" dirty="0">
                 <a:solidFill>
                   <a:srgbClr val="C4A35A"/>
@@ -11381,7 +11402,7 @@
                 </a:solidFill>
                 <a:latin typeface="Calibri"/>
               </a:rPr>
-              <a:t> / 26</a:t>
+              <a:t> / 29</a:t>
             </a:r>
             <a:endParaRPr lang="en-GB" sz="1000"/>
           </a:p>
@@ -11940,7 +11961,7 @@
           <a:lstStyle/>
           <a:p>
             <a:pPr algn="l"/>
-            <a:fld id="{704cdfe1-bb1e-4d6b-b3d9-2461149855d1}" type="datetime3">
+            <a:fld id="{032c2daf-b888-42d3-8eb1-b0ec911c82dc}" type="datetime3">
               <a:rPr lang="en-GB" sz="1000" dirty="0">
                 <a:solidFill>
                   <a:srgbClr val="C4A35A"/>
@@ -11974,7 +11995,7 @@
           <a:lstStyle/>
           <a:p>
             <a:pPr algn="r"/>
-            <a:fld id="{30b8179a-6ca0-4b06-97c3-1c6b64e74919}" type="slidenum">
+            <a:fld id="{ba648479-646a-48ff-90db-39ed4006d22f}" type="slidenum">
               <a:rPr lang="en-GB" sz="1000" dirty="0">
                 <a:solidFill>
                   <a:srgbClr val="C4A35A"/>
@@ -11990,7 +12011,7 @@
                 </a:solidFill>
                 <a:latin typeface="Calibri"/>
               </a:rPr>
-              <a:t> / 26</a:t>
+              <a:t> / 29</a:t>
             </a:r>
             <a:endParaRPr lang="en-GB" sz="1000"/>
           </a:p>
@@ -12950,7 +12971,7 @@
           <a:lstStyle/>
           <a:p>
             <a:pPr algn="l"/>
-            <a:fld id="{147e2e15-6e62-4f2e-ac85-91666b268752}" type="datetime3">
+            <a:fld id="{b4579f13-7b13-4779-8530-c0ac35db377a}" type="datetime3">
               <a:rPr lang="en-GB" sz="1000" dirty="0">
                 <a:solidFill>
                   <a:srgbClr val="C4A35A"/>
@@ -12984,7 +13005,7 @@
           <a:lstStyle/>
           <a:p>
             <a:pPr algn="r"/>
-            <a:fld id="{bd60bcf4-ba63-48c9-ab7e-ebff9ff828d9}" type="slidenum">
+            <a:fld id="{d682814e-f95a-4a7f-8a83-8ecf758a7113}" type="slidenum">
               <a:rPr lang="en-GB" sz="1000" dirty="0">
                 <a:solidFill>
                   <a:srgbClr val="C4A35A"/>
@@ -13000,7 +13021,7 @@
                 </a:solidFill>
                 <a:latin typeface="Calibri"/>
               </a:rPr>
-              <a:t> / 26</a:t>
+              <a:t> / 29</a:t>
             </a:r>
             <a:endParaRPr lang="en-GB" sz="1000"/>
           </a:p>
@@ -13559,7 +13580,7 @@
           <a:lstStyle/>
           <a:p>
             <a:pPr algn="l"/>
-            <a:fld id="{f75fd1a7-97d2-4884-8cfc-54c63cb88625}" type="datetime3">
+            <a:fld id="{2c5e8bc4-e04b-4a2a-bff8-bd04950680f7}" type="datetime3">
               <a:rPr lang="en-GB" sz="1000" dirty="0">
                 <a:solidFill>
                   <a:srgbClr val="C4A35A"/>
@@ -13593,7 +13614,7 @@
           <a:lstStyle/>
           <a:p>
             <a:pPr algn="r"/>
-            <a:fld id="{316b1242-7c19-463b-929c-86b4db6df9f5}" type="slidenum">
+            <a:fld id="{dd327c99-9dc1-4ba4-9a1a-dd634cde3cd7}" type="slidenum">
               <a:rPr lang="en-GB" sz="1000" dirty="0">
                 <a:solidFill>
                   <a:srgbClr val="C4A35A"/>
@@ -13609,7 +13630,7 @@
                 </a:solidFill>
                 <a:latin typeface="Calibri"/>
               </a:rPr>
-              <a:t> / 26</a:t>
+              <a:t> / 29</a:t>
             </a:r>
             <a:endParaRPr lang="en-GB" sz="1000"/>
           </a:p>
@@ -14562,7 +14583,7 @@
           <a:lstStyle/>
           <a:p>
             <a:pPr algn="l"/>
-            <a:fld id="{728284ff-b9ef-4170-98bd-dff881033f42}" type="datetime3">
+            <a:fld id="{ff9e8050-41f1-4cd5-ad4a-571a72a3d51e}" type="datetime3">
               <a:rPr lang="en-GB" sz="1000" dirty="0">
                 <a:solidFill>
                   <a:srgbClr val="C4A35A"/>
@@ -14596,7 +14617,7 @@
           <a:lstStyle/>
           <a:p>
             <a:pPr algn="r"/>
-            <a:fld id="{b3ecf6fa-66dd-42fb-9fda-b57058a43207}" type="slidenum">
+            <a:fld id="{984b57e9-b723-4113-a13c-1a03bfa36444}" type="slidenum">
               <a:rPr lang="en-GB" sz="1000" dirty="0">
                 <a:solidFill>
                   <a:srgbClr val="C4A35A"/>
@@ -14612,7 +14633,7 @@
                 </a:solidFill>
                 <a:latin typeface="Calibri"/>
               </a:rPr>
-              <a:t> / 26</a:t>
+              <a:t> / 29</a:t>
             </a:r>
             <a:endParaRPr lang="en-GB" sz="1000"/>
           </a:p>
@@ -14944,7 +14965,7 @@
                 </a:solidFill>
                 <a:latin typeface="Calibri"/>
               </a:rPr>
-              <a:t>RESEARCH PROPOSAL  ·  Conclusion</a:t>
+              <a:t>RESEARCH PROPOSAL  ·  Research Methodology</a:t>
             </a:r>
           </a:p>
         </p:txBody>
@@ -14979,7 +15000,7 @@
                 </a:solidFill>
                 <a:latin typeface="Calibri"/>
               </a:rPr>
-              <a:t>Conclusion</a:t>
+              <a:t>Research Methodology — implementation formulas</a:t>
             </a:r>
           </a:p>
         </p:txBody>
@@ -15014,124 +15035,378 @@
                 </a:solidFill>
                 <a:latin typeface="Calibri"/>
               </a:rPr>
-              <a:t>ACRS is proposed as a structural orchestration layer. The contribution is the closed loop and the four named gaps — not a pre-committed leaderboard.</a:t>
-            </a:r>
-          </a:p>
-        </p:txBody>
-      </p:sp>
-      <p:sp>
-        <p:nvSpPr>
-          <p:cNvPr id="12" name="TextBox 11"/>
-          <p:cNvSpPr txBox="1"/>
-          <p:nvPr/>
-        </p:nvSpPr>
-        <p:spPr>
-          <a:xfrm>
-            <a:off x="365760" y="2212848"/>
-            <a:ext cx="11430000" cy="3977639"/>
-          </a:xfrm>
-          <a:prstGeom prst="rect">
-            <a:avLst/>
-          </a:prstGeom>
-          <a:noFill/>
-        </p:spPr>
-        <p:txBody>
-          <a:bodyPr wrap="square">
-            <a:spAutoFit/>
-          </a:bodyPr>
-          <a:lstStyle/>
-          <a:p>
-            <a:pPr>
-              <a:spcAft>
-                <a:spcPts val="600"/>
-              </a:spcAft>
-              <a:buFont typeface="Arial"/>
-              <a:buChar char="•"/>
-            </a:pPr>
-            <a:r>
-              <a:rPr sz="1300">
-                <a:solidFill>
-                  <a:srgbClr val="1A1214"/>
-                </a:solidFill>
-                <a:latin typeface="Calibri"/>
-              </a:rPr>
-              <a:t>The literature (AutoGen, MetaGPT, ChatDev, CAMEL, ToolLLM, MasRouter, RouteLLM, PILOT, LLMLingua, PECAD) establishes conversation, tools, learned routing, and prompt compression. It does not establish SATR → APRR → MNCD → FCNP as one contract over live Indian OGD.</a:t>
-            </a:r>
-          </a:p>
-          <a:p>
-            <a:pPr>
-              <a:spcAft>
-                <a:spcPts val="600"/>
-              </a:spcAft>
-              <a:buFont typeface="Arial"/>
-              <a:buChar char="•"/>
-            </a:pPr>
-            <a:r>
-              <a:rPr sz="1300">
-                <a:solidFill>
-                  <a:srgbClr val="1A1214"/>
-                </a:solidFill>
-                <a:latin typeface="Calibri"/>
-              </a:rPr>
-              <a:t>The identified problem is five gaps: G1 session–tool fusion, G2 training-free specialist posterior, G3 live fail-loud Indian OGD, G4 conductance prune with write-back, G5 missing integration layer.</a:t>
-            </a:r>
-          </a:p>
-          <a:p>
-            <a:pPr>
-              <a:spcAft>
-                <a:spcPts val="600"/>
-              </a:spcAft>
-              <a:buFont typeface="Arial"/>
-              <a:buChar char="•"/>
-            </a:pPr>
-            <a:r>
-              <a:rPr sz="1300">
-                <a:solidFill>
-                  <a:srgbClr val="1A1214"/>
-                </a:solidFill>
-                <a:latin typeface="Calibri"/>
-              </a:rPr>
-              <a:t>The aim is to design that layer. Four objectives (SATR, APRR, MNCD, FCNP) and four research questions map onto it.</a:t>
-            </a:r>
-          </a:p>
-          <a:p>
-            <a:pPr>
-              <a:spcAft>
-                <a:spcPts val="600"/>
-              </a:spcAft>
-              <a:buFont typeface="Arial"/>
-              <a:buChar char="•"/>
-            </a:pPr>
-            <a:r>
-              <a:rPr sz="1300">
-                <a:solidFill>
-                  <a:srgbClr val="1A1214"/>
-                </a:solidFill>
-                <a:latin typeface="Calibri"/>
-              </a:rPr>
-              <a:t>Methodology is specified per objective: ToolBench as ranking library; Dirichlet–Thompson routing; verified data.gov.in UUIDs with score-sum; Physarum-inspired prune with SATR write-back. Metric numbers are deferred.</a:t>
-            </a:r>
-          </a:p>
-          <a:p>
-            <a:pPr>
-              <a:spcAft>
-                <a:spcPts val="600"/>
-              </a:spcAft>
-              <a:buFont typeface="Arial"/>
-              <a:buChar char="•"/>
-            </a:pPr>
-            <a:r>
-              <a:rPr sz="1300">
-                <a:solidFill>
-                  <a:srgbClr val="1A1214"/>
-                </a:solidFill>
-                <a:latin typeface="Calibri"/>
-              </a:rPr>
-              <a:t>Next step after approval. Freeze evaluation protocols, implement the closed loop, and report whatever the measurements show — including negative results.</a:t>
-            </a:r>
-          </a:p>
-        </p:txBody>
-      </p:sp>
+              <a:t>How the proposal will be implemented: the equations copied from the laboratory, not a promised leaderboard. Constants are the repository defaults.</a:t>
+            </a:r>
+          </a:p>
+        </p:txBody>
+      </p:sp>
+      <p:graphicFrame>
+        <p:nvGraphicFramePr>
+          <p:cNvPr id="12" name="Table 11"/>
+          <p:cNvGraphicFramePr>
+            <a:graphicFrameLocks noGrp="1"/>
+          </p:cNvGraphicFramePr>
+          <p:nvPr/>
+        </p:nvGraphicFramePr>
+        <p:xfrm>
+          <a:off x="320040" y="2212848"/>
+          <a:ext cx="11521439" cy="4023360"/>
+        </p:xfrm>
+        <a:graphic>
+          <a:graphicData uri="http://schemas.openxmlformats.org/drawingml/2006/table">
+            <a:tbl>
+              <a:tblPr firstRow="1" bandRow="1">
+                <a:tableStyleId>{5C22544A-7EE6-4342-B048-85BDC9FD1C3A}</a:tableStyleId>
+              </a:tblPr>
+              <a:tblGrid>
+                <a:gridCol w="1843430"/>
+                <a:gridCol w="3917289"/>
+                <a:gridCol w="5760720"/>
+              </a:tblGrid>
+              <a:tr h="804672">
+                <a:tc>
+                  <a:txBody>
+                    <a:bodyPr/>
+                    <a:lstStyle/>
+                    <a:p>
+                      <a:r>
+                        <a:rPr b="1" sz="1100">
+                          <a:solidFill>
+                            <a:srgbClr val="FFFFFF"/>
+                          </a:solidFill>
+                          <a:latin typeface="Calibri"/>
+                        </a:rPr>
+                        <a:t>Module</a:t>
+                      </a:r>
+                    </a:p>
+                  </a:txBody>
+                  <a:tcPr>
+                    <a:solidFill>
+                      <a:srgbClr val="7C1D2E"/>
+                    </a:solidFill>
+                  </a:tcPr>
+                </a:tc>
+                <a:tc>
+                  <a:txBody>
+                    <a:bodyPr/>
+                    <a:lstStyle/>
+                    <a:p>
+                      <a:r>
+                        <a:rPr b="1" sz="1100">
+                          <a:solidFill>
+                            <a:srgbClr val="FFFFFF"/>
+                          </a:solidFill>
+                          <a:latin typeface="Calibri"/>
+                        </a:rPr>
+                        <a:t>Formula as coded</a:t>
+                      </a:r>
+                    </a:p>
+                  </a:txBody>
+                  <a:tcPr>
+                    <a:solidFill>
+                      <a:srgbClr val="7C1D2E"/>
+                    </a:solidFill>
+                  </a:tcPr>
+                </a:tc>
+                <a:tc>
+                  <a:txBody>
+                    <a:bodyPr/>
+                    <a:lstStyle/>
+                    <a:p>
+                      <a:r>
+                        <a:rPr b="1" sz="1100">
+                          <a:solidFill>
+                            <a:srgbClr val="FFFFFF"/>
+                          </a:solidFill>
+                          <a:latin typeface="Calibri"/>
+                        </a:rPr>
+                        <a:t>Constants</a:t>
+                      </a:r>
+                    </a:p>
+                  </a:txBody>
+                  <a:tcPr>
+                    <a:solidFill>
+                      <a:srgbClr val="7C1D2E"/>
+                    </a:solidFill>
+                  </a:tcPr>
+                </a:tc>
+              </a:tr>
+              <a:tr h="804672">
+                <a:tc>
+                  <a:txBody>
+                    <a:bodyPr/>
+                    <a:lstStyle/>
+                    <a:p>
+                      <a:r>
+                        <a:rPr sz="1000" b="1">
+                          <a:solidFill>
+                            <a:srgbClr val="7C1D2E"/>
+                          </a:solidFill>
+                          <a:latin typeface="Calibri"/>
+                        </a:rPr>
+                        <a:t>O1 SATR</a:t>
+                      </a:r>
+                    </a:p>
+                  </a:txBody>
+                  <a:tcPr>
+                    <a:solidFill>
+                      <a:srgbClr val="FFFAF3"/>
+                    </a:solidFill>
+                  </a:tcPr>
+                </a:tc>
+                <a:tc>
+                  <a:txBody>
+                    <a:bodyPr/>
+                    <a:lstStyle/>
+                    <a:p>
+                      <a:r>
+                        <a:rPr sz="1000">
+                          <a:solidFill>
+                            <a:srgbClr val="1A1214"/>
+                          </a:solidFill>
+                          <a:latin typeface="Calibri"/>
+                        </a:rPr>
+                        <a:t>s(a|q,H)=w_base s_base + w_cat cat + w_sch sch + w_ept ept + w_cooc Σ γ^{n-i} log(1+w_{h_i,a}) + w_rec rec − 0.35 fails;  s_base=0.7 BM25+0.3 TFIDF-cos+0.08 mem-cos</a:t>
+                      </a:r>
+                    </a:p>
+                  </a:txBody>
+                  <a:tcPr>
+                    <a:solidFill>
+                      <a:srgbClr val="FFFAF3"/>
+                    </a:solidFill>
+                  </a:tcPr>
+                </a:tc>
+                <a:tc>
+                  <a:txBody>
+                    <a:bodyPr/>
+                    <a:lstStyle/>
+                    <a:p>
+                      <a:r>
+                        <a:rPr sz="1000">
+                          <a:solidFill>
+                            <a:srgbClr val="1A1214"/>
+                          </a:solidFill>
+                          <a:latin typeface="Calibri"/>
+                        </a:rPr>
+                        <a:t>w=(1, 0.45, 0.25, 0.3, 0.35, 0.25); γ=0.7; ρ=0.02; δ=1; decay=0.85; BM25 k1=1.5 b=0.75</a:t>
+                      </a:r>
+                    </a:p>
+                  </a:txBody>
+                  <a:tcPr>
+                    <a:solidFill>
+                      <a:srgbClr val="FFFAF3"/>
+                    </a:solidFill>
+                  </a:tcPr>
+                </a:tc>
+              </a:tr>
+              <a:tr h="804672">
+                <a:tc>
+                  <a:txBody>
+                    <a:bodyPr/>
+                    <a:lstStyle/>
+                    <a:p>
+                      <a:r>
+                        <a:rPr sz="1000" b="1">
+                          <a:solidFill>
+                            <a:srgbClr val="7C1D2E"/>
+                          </a:solidFill>
+                          <a:latin typeface="Calibri"/>
+                        </a:rPr>
+                        <a:t>O2 APRR</a:t>
+                      </a:r>
+                    </a:p>
+                  </a:txBody>
+                  <a:tcPr>
+                    <a:solidFill>
+                      <a:srgbClr val="FFFAF3"/>
+                    </a:solidFill>
+                  </a:tcPr>
+                </a:tc>
+                <a:tc>
+                  <a:txBody>
+                    <a:bodyPr/>
+                    <a:lstStyle/>
+                    <a:p>
+                      <a:r>
+                        <a:rPr sz="1000">
+                          <a:solidFill>
+                            <a:srgbClr val="1A1214"/>
+                          </a:solidFill>
+                          <a:latin typeface="Calibri"/>
+                        </a:rPr>
+                        <a:t>P(a_j|a_i,q) ∝ W_ij^α η_ij^β ψ_j(q)^γ ;  W←(1-λ)W + κ·reward·1/L²·1/lat</a:t>
+                      </a:r>
+                    </a:p>
+                  </a:txBody>
+                  <a:tcPr>
+                    <a:solidFill>
+                      <a:srgbClr val="FFFAF3"/>
+                    </a:solidFill>
+                  </a:tcPr>
+                </a:tc>
+                <a:tc>
+                  <a:txBody>
+                    <a:bodyPr/>
+                    <a:lstStyle/>
+                    <a:p>
+                      <a:r>
+                        <a:rPr sz="1000">
+                          <a:solidFill>
+                            <a:srgbClr val="1A1214"/>
+                          </a:solidFill>
+                          <a:latin typeface="Calibri"/>
+                        </a:rPr>
+                        <a:t>α=2, β=1, γ=2.5, λ=0.005, κ=5, W0=0.1, ε=0 (lab), maxHops=4; reward +1 / −0.05</a:t>
+                      </a:r>
+                    </a:p>
+                  </a:txBody>
+                  <a:tcPr>
+                    <a:solidFill>
+                      <a:srgbClr val="FFFAF3"/>
+                    </a:solidFill>
+                  </a:tcPr>
+                </a:tc>
+              </a:tr>
+              <a:tr h="804672">
+                <a:tc>
+                  <a:txBody>
+                    <a:bodyPr/>
+                    <a:lstStyle/>
+                    <a:p>
+                      <a:r>
+                        <a:rPr sz="1000" b="1">
+                          <a:solidFill>
+                            <a:srgbClr val="7C1D2E"/>
+                          </a:solidFill>
+                          <a:latin typeface="Calibri"/>
+                        </a:rPr>
+                        <a:t>O3 MNCD</a:t>
+                      </a:r>
+                    </a:p>
+                  </a:txBody>
+                  <a:tcPr>
+                    <a:solidFill>
+                      <a:srgbClr val="FFFAF3"/>
+                    </a:solidFill>
+                  </a:tcPr>
+                </a:tc>
+                <a:tc>
+                  <a:txBody>
+                    <a:bodyPr/>
+                    <a:lstStyle/>
+                    <a:p>
+                      <a:r>
+                        <a:rPr sz="1000">
+                          <a:solidFill>
+                            <a:srgbClr val="1A1214"/>
+                          </a:solidFill>
+                          <a:latin typeface="Calibri"/>
+                        </a:rPr>
+                        <a:t>s=0.45 score/(|score|+2)+0.35 overlap+liveBoost−0.05 idx;  tally=Σ w_a s_a;  w=success/(1+lat/1000)</a:t>
+                      </a:r>
+                    </a:p>
+                  </a:txBody>
+                  <a:tcPr>
+                    <a:solidFill>
+                      <a:srgbClr val="FFFAF3"/>
+                    </a:solidFill>
+                  </a:tcPr>
+                </a:tc>
+                <a:tc>
+                  <a:txBody>
+                    <a:bodyPr/>
+                    <a:lstStyle/>
+                    <a:p>
+                      <a:r>
+                        <a:rPr sz="1000">
+                          <a:solidFill>
+                            <a:srgbClr val="1A1214"/>
+                          </a:solidFill>
+                          <a:latin typeface="Calibri"/>
+                        </a:rPr>
+                        <a:t>liveBoost 0.25+0.20 preferred; fanout=3; R=2; τ=0.55; score-sum not Borda; live UUID only</a:t>
+                      </a:r>
+                    </a:p>
+                  </a:txBody>
+                  <a:tcPr>
+                    <a:solidFill>
+                      <a:srgbClr val="FFFAF3"/>
+                    </a:solidFill>
+                  </a:tcPr>
+                </a:tc>
+              </a:tr>
+              <a:tr h="804672">
+                <a:tc>
+                  <a:txBody>
+                    <a:bodyPr/>
+                    <a:lstStyle/>
+                    <a:p>
+                      <a:r>
+                        <a:rPr sz="1000" b="1">
+                          <a:solidFill>
+                            <a:srgbClr val="7C1D2E"/>
+                          </a:solidFill>
+                          <a:latin typeface="Calibri"/>
+                        </a:rPr>
+                        <a:t>O4 FCNP</a:t>
+                      </a:r>
+                    </a:p>
+                  </a:txBody>
+                  <a:tcPr>
+                    <a:solidFill>
+                      <a:srgbClr val="FFFAF3"/>
+                    </a:solidFill>
+                  </a:tcPr>
+                </a:tc>
+                <a:tc>
+                  <a:txBody>
+                    <a:bodyPr/>
+                    <a:lstStyle/>
+                    <a:p>
+                      <a:r>
+                        <a:rPr sz="1000">
+                          <a:solidFill>
+                            <a:srgbClr val="1A1214"/>
+                          </a:solidFill>
+                          <a:latin typeface="Calibri"/>
+                        </a:rPr>
+                        <a:t>D_ij(t+1)=(1-μ)D_ij+α|Q_ij|^γ ;  L p = I ;  Q=|D(p_i-p_j)|;  keep 35% / summarize 20% / drop</a:t>
+                      </a:r>
+                    </a:p>
+                  </a:txBody>
+                  <a:tcPr>
+                    <a:solidFill>
+                      <a:srgbClr val="FFFAF3"/>
+                    </a:solidFill>
+                  </a:tcPr>
+                </a:tc>
+                <a:tc>
+                  <a:txBody>
+                    <a:bodyPr/>
+                    <a:lstStyle/>
+                    <a:p>
+                      <a:r>
+                        <a:rPr sz="1000">
+                          <a:solidFill>
+                            <a:srgbClr val="1A1214"/>
+                          </a:solidFill>
+                          <a:latin typeface="Calibri"/>
+                        </a:rPr>
+                        <a:t>μ=0.1, α=0.5, γ=1.2, sim≥0.12; pinned live citations never evicted; memory→SATR</a:t>
+                      </a:r>
+                    </a:p>
+                  </a:txBody>
+                  <a:tcPr>
+                    <a:solidFill>
+                      <a:srgbClr val="FFFAF3"/>
+                    </a:solidFill>
+                  </a:tcPr>
+                </a:tc>
+              </a:tr>
+            </a:tbl>
+          </a:graphicData>
+        </a:graphic>
+      </p:graphicFrame>
       <p:sp>
         <p:nvSpPr>
           <p:cNvPr id="4022" name="Automatic Date 22"/>
@@ -15153,7 +15428,7 @@
           <a:lstStyle/>
           <a:p>
             <a:pPr algn="l"/>
-            <a:fld id="{20464716-b496-404f-9990-0057820e99ff}" type="datetime3">
+            <a:fld id="{b20bf3b9-d51c-4b89-bd7a-b90e39ccf131}" type="datetime3">
               <a:rPr lang="en-GB" sz="1000" dirty="0">
                 <a:solidFill>
                   <a:srgbClr val="C4A35A"/>
@@ -15187,7 +15462,7 @@
           <a:lstStyle/>
           <a:p>
             <a:pPr algn="r"/>
-            <a:fld id="{2f39b963-498f-4ead-8c17-0c4ced818f40}" type="slidenum">
+            <a:fld id="{5158a0a1-7ea9-42d5-8f43-15f073790545}" type="slidenum">
               <a:rPr lang="en-GB" sz="1000" dirty="0">
                 <a:solidFill>
                   <a:srgbClr val="C4A35A"/>
@@ -15203,7 +15478,7 @@
                 </a:solidFill>
                 <a:latin typeface="Calibri"/>
               </a:rPr>
-              <a:t> / 26</a:t>
+              <a:t> / 29</a:t>
             </a:r>
             <a:endParaRPr lang="en-GB" sz="1000"/>
           </a:p>
@@ -15535,7 +15810,7 @@
                 </a:solidFill>
                 <a:latin typeface="Calibri"/>
               </a:rPr>
-              <a:t>RESEARCH PROPOSAL  ·  References 1/3</a:t>
+              <a:t>RESEARCH PROPOSAL  ·  Research Methodology</a:t>
             </a:r>
           </a:p>
         </p:txBody>
@@ -15570,7 +15845,7 @@
                 </a:solidFill>
                 <a:latin typeface="Calibri"/>
               </a:rPr>
-              <a:t>References (1/3) — multi-agent systems and tool learning</a:t>
+              <a:t>Research Methodology — ToolBench walkthrough</a:t>
             </a:r>
           </a:p>
         </p:txBody>
@@ -15584,6 +15859,41 @@
         <p:spPr>
           <a:xfrm>
             <a:off x="365760" y="1572768"/>
+            <a:ext cx="11430000" cy="640080"/>
+          </a:xfrm>
+          <a:prstGeom prst="rect">
+            <a:avLst/>
+          </a:prstGeom>
+          <a:noFill/>
+        </p:spPr>
+        <p:txBody>
+          <a:bodyPr wrap="square">
+            <a:spAutoFit/>
+          </a:bodyPr>
+          <a:lstStyle/>
+          <a:p>
+            <a:pPr algn="l"/>
+            <a:r>
+              <a:rPr sz="1400" b="0">
+                <a:solidFill>
+                  <a:srgbClr val="5C4A4E"/>
+                </a:solidFill>
+                <a:latin typeface="Calibri"/>
+              </a:rPr>
+              <a:t>One ToolBench-schema datum, processed by all four objectives. RapidAPI is never GET. Numbers are a 07 September 2026 lab trace, not a metric claim.</a:t>
+            </a:r>
+          </a:p>
+        </p:txBody>
+      </p:sp>
+      <p:sp>
+        <p:nvSpPr>
+          <p:cNvPr id="12" name="TextBox 11"/>
+          <p:cNvSpPr txBox="1"/>
+          <p:nvPr/>
+        </p:nvSpPr>
+        <p:spPr>
+          <a:xfrm>
+            <a:off x="365760" y="2212848"/>
             <a:ext cx="11430000" cy="3977639"/>
           </a:xfrm>
           <a:prstGeom prst="rect">
@@ -15611,7 +15921,7 @@
                 </a:solidFill>
                 <a:latin typeface="Calibri"/>
               </a:rPr>
-              <a:t>Wu, Q., Bansal, G., Zhang, J., Wu, Y., Li, B., Zhu, E., Jiang, L., Zhang, X., Zhang, S., Liu, J., Awadallah, A. H., White, R. W., Burger, D., and Wang, C. AutoGen: Enabling Next-Gen LLM Applications via Multi-Agent Conversation. ICLR 2024 Workshop on Large Language Model (LLM) Agents; also COLM 2024. arXiv:2308.08155.</a:t>
+              <a:t>Intake. Bundled G1 jsonl qid=6491 is a RapidAPI aircraft query (gold docs 4308–4317). Off-sector flights are stripped. The ranking-library analogue walked here is tb.agri.soil_health with q = “What is the soil pH and recommended fertilizer dose for a farm village?”</a:t>
             </a:r>
           </a:p>
           <a:p>
@@ -15629,7 +15939,7 @@
                 </a:solidFill>
                 <a:latin typeface="Calibri"/>
               </a:rPr>
-              <a:t>Hong, S., Zhuge, M., Chen, J., Zheng, X., Cheng, Y., Wang, J., Zhang, C., Wang, Z., Yau, S. K. S., Lin, Z., Zhou, L., Ran, C., Xiao, L., Wu, C., and Schmidhuber, J. MetaGPT: Meta Programming for A Multi-Agent Collaborative Framework. ICLR 2024.</a:t>
+              <a:t>O1 SATR. Cold start so s=z(s_base). tb.agri.soil_health s_base=18.08 → s=5.40 (rank 1, ranking-only). karnataka::shc_karnataka s=1.40. datagov.fertilizer s=0.60 (live, rank 4).</a:t>
             </a:r>
           </a:p>
           <a:p>
@@ -15647,7 +15957,7 @@
                 </a:solidFill>
                 <a:latin typeface="Calibri"/>
               </a:rPr>
-              <a:t>Li, G., Hammoud, H. A. A. K., Itani, H., Khizbullin, D., and Ghanem, B. CAMEL: Communicative Agents for “Mind” Exploration of Large Language Model Society. NeurIPS 2023.</a:t>
+              <a:t>O2 APRR. Path agriculture_analyst → schema_planner (p=0.73) → retrieval_specialist (p=0.95). Non-Agriculture specialists fall back to SATR #1 = soil_health.</a:t>
             </a:r>
           </a:p>
           <a:p>
@@ -15665,7 +15975,7 @@
                 </a:solidFill>
                 <a:latin typeface="Calibri"/>
               </a:rPr>
-              <a:t>Qian, C., Liu, W., Liu, H., Chen, N., Dang, Y., Li, J., Yang, C., Chen, W., Su, Y., Cong, X., Xu, J., Li, D., Liu, Z., and Sun, M. ChatDev: Communicative Agents for Software Development. ACL 2024. arXiv:2307.07924.</a:t>
+              <a:t>O3 MNCD. Agent score s=0.45 score/(|score|+2)+0.35 overlap. soil_health 0.5995; tally=3·0.7407·0.5995=1.332. Not liveExecutable. preferredLiveToolId matches fertilizer → GET UUID 2e0e6c04-97f2-456b-9309-bf605650cb11 (44 live subsidy rows, e.g. 2002-03 Indigenous Urea 7790 Rs crore).</a:t>
             </a:r>
           </a:p>
           <a:p>
@@ -15683,25 +15993,42 @@
                 </a:solidFill>
                 <a:latin typeface="Calibri"/>
               </a:rPr>
-              <a:t>Qin, Y., Liang, S., Ye, Y., Zhu, K., Yan, L., Lu, Y., Lin, Y., Cong, X., Tang, X., Qian, B., Zhao, S., Hong, L., Tian, R., Xie, R., Zhou, J., Gerstein, M., Li, D., Liu, Z., and Sun, M. ToolLLM: Facilitating Large Language Models to Master 16000+ Real-world APIs. ICLR 2024.</a:t>
-            </a:r>
-          </a:p>
-          <a:p>
-            <a:pPr>
-              <a:spcAft>
-                <a:spcPts val="600"/>
-              </a:spcAft>
-              <a:buFont typeface="Arial"/>
-              <a:buChar char="•"/>
-            </a:pPr>
-            <a:r>
-              <a:rPr sz="1300">
-                <a:solidFill>
-                  <a:srgbClr val="1A1214"/>
-                </a:solidFill>
-                <a:latin typeface="Calibri"/>
-              </a:rPr>
-              <a:t>Zheng, Y., Li, P., Liu, W., Liu, Y., Luan, J., and Wang, B. ToolRerank: Adaptive and Hierarchy-Aware Reranking for Tool Retrieval. LREC-COLING 2024.</a:t>
+              <a:t>O4 FCNP. 10 spans → keep 6 / drop 4; pin query + live fertilizer observation + citation. Memory written back to SATR.</a:t>
+            </a:r>
+          </a:p>
+        </p:txBody>
+      </p:sp>
+      <p:sp>
+        <p:nvSpPr>
+          <p:cNvPr id="13" name="TextBox 12"/>
+          <p:cNvSpPr txBox="1"/>
+          <p:nvPr/>
+        </p:nvSpPr>
+        <p:spPr>
+          <a:xfrm>
+            <a:off x="365760" y="6199632"/>
+            <a:ext cx="11430000" cy="256032"/>
+          </a:xfrm>
+          <a:prstGeom prst="rect">
+            <a:avLst/>
+          </a:prstGeom>
+          <a:noFill/>
+        </p:spPr>
+        <p:txBody>
+          <a:bodyPr wrap="square">
+            <a:spAutoFit/>
+          </a:bodyPr>
+          <a:lstStyle/>
+          <a:p>
+            <a:pPr algn="l"/>
+            <a:r>
+              <a:rPr sz="1000" b="0">
+                <a:solidFill>
+                  <a:srgbClr val="5C4A4E"/>
+                </a:solidFill>
+                <a:latin typeface="Calibri"/>
+              </a:rPr>
+              <a:t>ToolBench = ranking library. Live evidence is always a verified data.gov.in Agriculture UUID.</a:t>
             </a:r>
           </a:p>
         </p:txBody>
@@ -15727,7 +16054,7 @@
           <a:lstStyle/>
           <a:p>
             <a:pPr algn="l"/>
-            <a:fld id="{e41c3b7c-47bd-4c4a-9de3-37c03bbcd3f1}" type="datetime3">
+            <a:fld id="{d9cf41e1-6d2e-407a-b496-da6b73f15326}" type="datetime3">
               <a:rPr lang="en-GB" sz="1000" dirty="0">
                 <a:solidFill>
                   <a:srgbClr val="C4A35A"/>
@@ -15761,7 +16088,7 @@
           <a:lstStyle/>
           <a:p>
             <a:pPr algn="r"/>
-            <a:fld id="{fe3122eb-362a-4ec6-862d-2115be9a0339}" type="slidenum">
+            <a:fld id="{4567793e-acda-4149-b8eb-eca6c8b5c0e2}" type="slidenum">
               <a:rPr lang="en-GB" sz="1000" dirty="0">
                 <a:solidFill>
                   <a:srgbClr val="C4A35A"/>
@@ -15777,7 +16104,7 @@
                 </a:solidFill>
                 <a:latin typeface="Calibri"/>
               </a:rPr>
-              <a:t> / 26</a:t>
+              <a:t> / 29</a:t>
             </a:r>
             <a:endParaRPr lang="en-GB" sz="1000"/>
           </a:p>
@@ -16109,7 +16436,7 @@
                 </a:solidFill>
                 <a:latin typeface="Calibri"/>
               </a:rPr>
-              <a:t>RESEARCH PROPOSAL  ·  References 2/3</a:t>
+              <a:t>RESEARCH PROPOSAL  ·  Research Methodology</a:t>
             </a:r>
           </a:p>
         </p:txBody>
@@ -16144,7 +16471,7 @@
                 </a:solidFill>
                 <a:latin typeface="Calibri"/>
               </a:rPr>
-              <a:t>References (2/3) — routing, compression, reasoning, biology</a:t>
+              <a:t>Research Methodology — data.gov.in walkthrough</a:t>
             </a:r>
           </a:p>
         </p:txBody>
@@ -16158,6 +16485,41 @@
         <p:spPr>
           <a:xfrm>
             <a:off x="365760" y="1572768"/>
+            <a:ext cx="11430000" cy="640080"/>
+          </a:xfrm>
+          <a:prstGeom prst="rect">
+            <a:avLst/>
+          </a:prstGeom>
+          <a:noFill/>
+        </p:spPr>
+        <p:txBody>
+          <a:bodyPr wrap="square">
+            <a:spAutoFit/>
+          </a:bodyPr>
+          <a:lstStyle/>
+          <a:p>
+            <a:pPr algn="l"/>
+            <a:r>
+              <a:rPr sz="1400" b="0">
+                <a:solidFill>
+                  <a:srgbClr val="5C4A4E"/>
+                </a:solidFill>
+                <a:latin typeface="Calibri"/>
+              </a:rPr>
+              <a:t>The same four objectives on live AGMARKNET. Query: “What is the current mandi price of wheat in Punjab?” Fail-loud: no invented Punjab-wheat modal.</a:t>
+            </a:r>
+          </a:p>
+        </p:txBody>
+      </p:sp>
+      <p:sp>
+        <p:nvSpPr>
+          <p:cNvPr id="12" name="TextBox 11"/>
+          <p:cNvSpPr txBox="1"/>
+          <p:nvPr/>
+        </p:nvSpPr>
+        <p:spPr>
+          <a:xfrm>
+            <a:off x="365760" y="2212848"/>
             <a:ext cx="11430000" cy="3977639"/>
           </a:xfrm>
           <a:prstGeom prst="rect">
@@ -16185,7 +16547,7 @@
                 </a:solidFill>
                 <a:latin typeface="Calibri"/>
               </a:rPr>
-              <a:t>Ong, I., Almahairi, A., Wu, V., Chiang, W.-L., Wu, T., Gonzalez, J. E., Kadous, M. W., and Stoica, I. RouteLLM: Learning to Route LLMs with Preference Data. arXiv:2406.18665, 2024.</a:t>
+              <a:t>Intake. extractToolArguments → state=Punjab, commodity=Wheat. preferredLiveToolId → datagov.mandi_prices (UUID 9ef84268-d588-465a-a308-a864a43d0070). Limit capped at 10 000.</a:t>
             </a:r>
           </a:p>
           <a:p>
@@ -16203,7 +16565,7 @@
                 </a:solidFill>
                 <a:latin typeface="Calibri"/>
               </a:rPr>
-              <a:t>Panda, S., and co-authors. PILOT: Preference-informed LinUCB for routing among language models. Findings of EMNLP 2025.</a:t>
+              <a:t>O1 SATR. karnataka::agmarknet_ka s=3.73 (rank 1, same UUID); datagov.mandi_prices s=3.05 (rank 2, preferred); datagov.msp s=2.31 (ranking-only).</a:t>
             </a:r>
           </a:p>
           <a:p>
@@ -16221,7 +16583,7 @@
                 </a:solidFill>
                 <a:latin typeface="Calibri"/>
               </a:rPr>
-              <a:t>Yue, Y., Zhang, G., Liu, B., Wan, G., Wang, K., Cheng, D., and Qi, Y. MasRouter: Learning to Route LLMs for Multi-Agent Systems. ACL 2025 (long). doi:10.18653/v1/2025.acl-long.757.</a:t>
+              <a:t>O2 APRR. Path agriculture_analyst → schema_planner (p=0.54) → tool_executor (p=0.66, terminal stop). Hop 0: Karnataka mandi, national mandi, MSP. Hop 2 live leftover: crop_production.</a:t>
             </a:r>
           </a:p>
           <a:p>
@@ -16239,7 +16601,7 @@
                 </a:solidFill>
                 <a:latin typeface="Calibri"/>
               </a:rPr>
-              <a:t>Jiang, H., Wu, Q., Lin, C.-Y., Yang, Y., and Qiu, L. LLMLingua: Compressing Prompts for Accelerated Inference of Large Language Models. EMNLP 2023.</a:t>
+              <a:t>O3 MNCD. mandi_prices agent-score 0.787 (liveBoost 0.45); karnataka 0.7789. Score-sum winner karnataka::agmarknet_ka tally=1.154. Live GET: 10 000 arrivals; 0 Wheat in Punjab today; 479 other live Punjab rows; Wheat in 133 live rows from MP, Rajasthan, UP, Gujarat, Maharashtra, West Bengal, Chhattisgarh. Shown mean modal Rs 2593/quintal (e.g. Bhindi, Dera Baba Nanak APMC, Rs 828, 07/09/2026).</a:t>
             </a:r>
           </a:p>
           <a:p>
@@ -16257,61 +16619,42 @@
                 </a:solidFill>
                 <a:latin typeface="Calibri"/>
               </a:rPr>
-              <a:t>Wei, J., Wang, X., Schuurmans, D., Bosma, M., Ichter, B., Xia, F., Chi, E., Le, Q., and Zhou, D. Chain-of-Thought Prompting Elicits Reasoning in Large Language Models. NeurIPS 2022.</a:t>
-            </a:r>
-          </a:p>
-          <a:p>
-            <a:pPr>
-              <a:spcAft>
-                <a:spcPts val="600"/>
-              </a:spcAft>
-              <a:buFont typeface="Arial"/>
-              <a:buChar char="•"/>
-            </a:pPr>
-            <a:r>
-              <a:rPr sz="1300">
-                <a:solidFill>
-                  <a:srgbClr val="1A1214"/>
-                </a:solidFill>
-                <a:latin typeface="Calibri"/>
-              </a:rPr>
-              <a:t>Yao, S., Zhao, J., Yu, D., Du, N., Shafran, I., Narasimhan, K., and Cao, Y. ReAct: Synergizing Reasoning and Acting in Language Models. ICLR 2023.</a:t>
-            </a:r>
-          </a:p>
-          <a:p>
-            <a:pPr>
-              <a:spcAft>
-                <a:spcPts val="600"/>
-              </a:spcAft>
-              <a:buFont typeface="Arial"/>
-              <a:buChar char="•"/>
-            </a:pPr>
-            <a:r>
-              <a:rPr sz="1300">
-                <a:solidFill>
-                  <a:srgbClr val="1A1214"/>
-                </a:solidFill>
-                <a:latin typeface="Calibri"/>
-              </a:rPr>
-              <a:t>Yao, S., Yu, D., Zhao, J., Shafran, I., Griffiths, T. L., Cao, Y., and Narasimhan, K. Tree of Thoughts: Deliberate Problem Solving with Large Language Models. NeurIPS 2023.</a:t>
-            </a:r>
-          </a:p>
-          <a:p>
-            <a:pPr>
-              <a:spcAft>
-                <a:spcPts val="600"/>
-              </a:spcAft>
-              <a:buFont typeface="Arial"/>
-              <a:buChar char="•"/>
-            </a:pPr>
-            <a:r>
-              <a:rPr sz="1300">
-                <a:solidFill>
-                  <a:srgbClr val="1A1214"/>
-                </a:solidFill>
-                <a:latin typeface="Calibri"/>
-              </a:rPr>
-              <a:t>Tero, A., Takagi, S., Saigusa, T., Ito, K., Bebber, D. P., Fricker, M. D., Yumiki, K., Kobayashi, R., and Nakagaki, T. Rules for Biologically Inspired Adaptive Network Design. Science, 2010. doi:10.1126/science.1177894.</a:t>
+              <a:t>O4 FCNP. 10 spans → keep 7; pin the AGMARKNET citation. W ← (1-λ)W + κ·1/L²/lat on the hop path. Next SATR is session-conditioned.</a:t>
+            </a:r>
+          </a:p>
+        </p:txBody>
+      </p:sp>
+      <p:sp>
+        <p:nvSpPr>
+          <p:cNvPr id="13" name="TextBox 12"/>
+          <p:cNvSpPr txBox="1"/>
+          <p:nvPr/>
+        </p:nvSpPr>
+        <p:spPr>
+          <a:xfrm>
+            <a:off x="365760" y="6199632"/>
+            <a:ext cx="11430000" cy="256032"/>
+          </a:xfrm>
+          <a:prstGeom prst="rect">
+            <a:avLst/>
+          </a:prstGeom>
+          <a:noFill/>
+        </p:spPr>
+        <p:txBody>
+          <a:bodyPr wrap="square">
+            <a:spAutoFit/>
+          </a:bodyPr>
+          <a:lstStyle/>
+          <a:p>
+            <a:pPr algn="l"/>
+            <a:r>
+              <a:rPr sz="1000" b="0">
+                <a:solidFill>
+                  <a:srgbClr val="5C4A4E"/>
+                </a:solidFill>
+                <a:latin typeface="Calibri"/>
+              </a:rPr>
+              <a:t>Lab trace 07 September 2026. Re-run on /walkthrough; rows change daily. No dummy prices.</a:t>
             </a:r>
           </a:p>
         </p:txBody>
@@ -16337,7 +16680,7 @@
           <a:lstStyle/>
           <a:p>
             <a:pPr algn="l"/>
-            <a:fld id="{a7d57394-d6b8-42d7-984a-bd4414ba8111}" type="datetime3">
+            <a:fld id="{230c114c-225b-4fe2-8006-e59029bcbc42}" type="datetime3">
               <a:rPr lang="en-GB" sz="1000" dirty="0">
                 <a:solidFill>
                   <a:srgbClr val="C4A35A"/>
@@ -16371,7 +16714,7 @@
           <a:lstStyle/>
           <a:p>
             <a:pPr algn="r"/>
-            <a:fld id="{740a88ae-5d9d-4654-ae48-3b967af74764}" type="slidenum">
+            <a:fld id="{11c7c39a-e098-46df-90a0-d600553d3c72}" type="slidenum">
               <a:rPr lang="en-GB" sz="1000" dirty="0">
                 <a:solidFill>
                   <a:srgbClr val="C4A35A"/>
@@ -16387,7 +16730,7 @@
                 </a:solidFill>
                 <a:latin typeface="Calibri"/>
               </a:rPr>
-              <a:t> / 26</a:t>
+              <a:t> / 29</a:t>
             </a:r>
             <a:endParaRPr lang="en-GB" sz="1000"/>
           </a:p>
@@ -16719,7 +17062,7 @@
                 </a:solidFill>
                 <a:latin typeface="Calibri"/>
               </a:rPr>
-              <a:t>RESEARCH PROPOSAL  ·  References 3/3</a:t>
+              <a:t>RESEARCH PROPOSAL  ·  Conclusion</a:t>
             </a:r>
           </a:p>
         </p:txBody>
@@ -16754,7 +17097,7 @@
                 </a:solidFill>
                 <a:latin typeface="Calibri"/>
               </a:rPr>
-              <a:t>References (3/3) — memory, tools, Indian agricultural data</a:t>
+              <a:t>Conclusion</a:t>
             </a:r>
           </a:p>
         </p:txBody>
@@ -16768,6 +17111,41 @@
         <p:spPr>
           <a:xfrm>
             <a:off x="365760" y="1572768"/>
+            <a:ext cx="11430000" cy="640080"/>
+          </a:xfrm>
+          <a:prstGeom prst="rect">
+            <a:avLst/>
+          </a:prstGeom>
+          <a:noFill/>
+        </p:spPr>
+        <p:txBody>
+          <a:bodyPr wrap="square">
+            <a:spAutoFit/>
+          </a:bodyPr>
+          <a:lstStyle/>
+          <a:p>
+            <a:pPr algn="l"/>
+            <a:r>
+              <a:rPr sz="1400" b="0">
+                <a:solidFill>
+                  <a:srgbClr val="5C4A4E"/>
+                </a:solidFill>
+                <a:latin typeface="Calibri"/>
+              </a:rPr>
+              <a:t>ACRS is proposed as a structural orchestration layer. The contribution is the closed loop and the four named gaps — not a pre-committed leaderboard.</a:t>
+            </a:r>
+          </a:p>
+        </p:txBody>
+      </p:sp>
+      <p:sp>
+        <p:nvSpPr>
+          <p:cNvPr id="12" name="TextBox 11"/>
+          <p:cNvSpPr txBox="1"/>
+          <p:nvPr/>
+        </p:nvSpPr>
+        <p:spPr>
+          <a:xfrm>
+            <a:off x="365760" y="2212848"/>
             <a:ext cx="11430000" cy="3977639"/>
           </a:xfrm>
           <a:prstGeom prst="rect">
@@ -16795,7 +17173,7 @@
                 </a:solidFill>
                 <a:latin typeface="Calibri"/>
               </a:rPr>
-              <a:t>Park, J. S., O’Brien, J. C., Cai, C. J., Morris, M. R., Liang, P., and Bernstein, M. S. Generative Agents: Interactive Simulacra of Human Behavior. CHI 2023.</a:t>
+              <a:t>The literature (AutoGen, MetaGPT, ChatDev, CAMEL, ToolLLM, MasRouter, RouteLLM, PILOT, LLMLingua, PECAD) establishes conversation, tools, learned routing, and prompt compression. It does not establish SATR → APRR → MNCD → FCNP as one contract over live Indian OGD.</a:t>
             </a:r>
           </a:p>
           <a:p>
@@ -16813,7 +17191,7 @@
                 </a:solidFill>
                 <a:latin typeface="Calibri"/>
               </a:rPr>
-              <a:t>Shinn, N., Cassano, F., Berman, E., Gopinath, A., Narasimhan, K., and Yao, S. Reflexion: Language Agents with Verbal Reinforcement Learning. NeurIPS 2023.</a:t>
+              <a:t>The identified problem is five gaps: G1 session–tool fusion, G2 training-free specialist posterior, G3 live fail-loud Indian OGD, G4 conductance prune with write-back, G5 missing integration layer.</a:t>
             </a:r>
           </a:p>
           <a:p>
@@ -16831,7 +17209,7 @@
                 </a:solidFill>
                 <a:latin typeface="Calibri"/>
               </a:rPr>
-              <a:t>Shen, Y., Song, K., Tan, X., Li, D., Lu, W., and Zhuang, Y. HuggingGPT: Solving AI Tasks with ChatGPT and its Friends in Hugging Face. NeurIPS 2023.</a:t>
+              <a:t>The aim is to design that layer. Four objectives (SATR, APRR, MNCD, FCNP) and four research questions map onto it.</a:t>
             </a:r>
           </a:p>
           <a:p>
@@ -16849,7 +17227,7 @@
                 </a:solidFill>
                 <a:latin typeface="Calibri"/>
               </a:rPr>
-              <a:t>Schick, T., Dwivedi-Yu, J., Dessì, R., Raileanu, R., Lomeli, M., Zettlemoyer, L., Cancedda, N., and Scialom, T. Toolformer: Language Models Can Teach Themselves to Use Tools. NeurIPS 2023.</a:t>
+              <a:t>Methodology is specified per objective: ToolBench as ranking library; Dirichlet–Thompson routing; verified data.gov.in UUIDs with score-sum; Physarum-inspired prune with SATR write-back. Metric numbers are deferred.</a:t>
             </a:r>
           </a:p>
           <a:p>
@@ -16867,60 +17245,7 @@
                 </a:solidFill>
                 <a:latin typeface="Calibri"/>
               </a:rPr>
-              <a:t>Guo, H., Woodruff, A., and Yadav, A. Improving Lives of Indebted Farmers Using Deep Learning: Predicting Agricultural Produce Prices Using Convolutional Neural Networks (PECAD). AAAI 2020. doi:10.1609/aaai.v34i08.7039. AGMARKNET scrape for price prediction; cited here as Indian OGD precedent, not as a baseline this proposal claims to beat.</a:t>
-            </a:r>
-          </a:p>
-          <a:p>
-            <a:pPr>
-              <a:spcAft>
-                <a:spcPts val="600"/>
-              </a:spcAft>
-              <a:buFont typeface="Arial"/>
-              <a:buChar char="•"/>
-            </a:pPr>
-            <a:r>
-              <a:rPr sz="1300">
-                <a:solidFill>
-                  <a:srgbClr val="1A1214"/>
-                </a:solidFill>
-                <a:latin typeface="Calibri"/>
-              </a:rPr>
-              <a:t>Government of India. Open Government Data Platform India (data.gov.in); AGMARKNET resource 9ef84268-d588-465a-a308-a864a43d0070; Directorate of Economics and Statistics crop production; IMD rainfall series; Government Open Data License — India (GODL-India).</a:t>
-            </a:r>
-          </a:p>
-        </p:txBody>
-      </p:sp>
-      <p:sp>
-        <p:nvSpPr>
-          <p:cNvPr id="12" name="TextBox 11"/>
-          <p:cNvSpPr txBox="1"/>
-          <p:nvPr/>
-        </p:nvSpPr>
-        <p:spPr>
-          <a:xfrm>
-            <a:off x="365760" y="6199632"/>
-            <a:ext cx="11430000" cy="256032"/>
-          </a:xfrm>
-          <a:prstGeom prst="rect">
-            <a:avLst/>
-          </a:prstGeom>
-          <a:noFill/>
-        </p:spPr>
-        <p:txBody>
-          <a:bodyPr wrap="square">
-            <a:spAutoFit/>
-          </a:bodyPr>
-          <a:lstStyle/>
-          <a:p>
-            <a:pPr algn="l"/>
-            <a:r>
-              <a:rPr sz="1000" b="0">
-                <a:solidFill>
-                  <a:srgbClr val="5C4A4E"/>
-                </a:solidFill>
-                <a:latin typeface="Calibri"/>
-              </a:rPr>
-              <a:t>CrewAI is an engineering framework without a flagship peer-reviewed paper in this list; AutoGen and MetaGPT are the MAS citations.</a:t>
+              <a:t>Next step after approval. Freeze evaluation protocols, implement the closed loop, and report whatever the measurements show — including negative results.</a:t>
             </a:r>
           </a:p>
         </p:txBody>
@@ -16946,7 +17271,7 @@
           <a:lstStyle/>
           <a:p>
             <a:pPr algn="l"/>
-            <a:fld id="{09d31ef4-b9dd-4f41-987c-3952cd194080}" type="datetime3">
+            <a:fld id="{f416b8ab-dc34-4091-a64a-9724bed8fb74}" type="datetime3">
               <a:rPr lang="en-GB" sz="1000" dirty="0">
                 <a:solidFill>
                   <a:srgbClr val="C4A35A"/>
@@ -16980,7 +17305,7 @@
           <a:lstStyle/>
           <a:p>
             <a:pPr algn="r"/>
-            <a:fld id="{addbed0d-a0fe-485b-afbd-3297496087c3}" type="slidenum">
+            <a:fld id="{e5bc0dd9-8c55-4d78-b837-e643d138f5f8}" type="slidenum">
               <a:rPr lang="en-GB" sz="1000" dirty="0">
                 <a:solidFill>
                   <a:srgbClr val="C4A35A"/>
@@ -16996,7 +17321,7 @@
                 </a:solidFill>
                 <a:latin typeface="Calibri"/>
               </a:rPr>
-              <a:t> / 26</a:t>
+              <a:t> / 29</a:t>
             </a:r>
             <a:endParaRPr lang="en-GB" sz="1000"/>
           </a:p>
@@ -17328,7 +17653,7 @@
                 </a:solidFill>
                 <a:latin typeface="Calibri"/>
               </a:rPr>
-              <a:t>RESEARCH PROPOSAL  ·  Thank you</a:t>
+              <a:t>RESEARCH PROPOSAL  ·  References 1/3</a:t>
             </a:r>
           </a:p>
         </p:txBody>
@@ -17363,7 +17688,7 @@
                 </a:solidFill>
                 <a:latin typeface="Calibri"/>
               </a:rPr>
-              <a:t>Thank you</a:t>
+              <a:t>References (1/3) — multi-agent systems and tool learning</a:t>
             </a:r>
           </a:p>
         </p:txBody>
@@ -17377,41 +17702,6 @@
         <p:spPr>
           <a:xfrm>
             <a:off x="365760" y="1572768"/>
-            <a:ext cx="11430000" cy="640080"/>
-          </a:xfrm>
-          <a:prstGeom prst="rect">
-            <a:avLst/>
-          </a:prstGeom>
-          <a:noFill/>
-        </p:spPr>
-        <p:txBody>
-          <a:bodyPr wrap="square">
-            <a:spAutoFit/>
-          </a:bodyPr>
-          <a:lstStyle/>
-          <a:p>
-            <a:pPr algn="l"/>
-            <a:r>
-              <a:rPr sz="1400" b="0">
-                <a:solidFill>
-                  <a:srgbClr val="5C4A4E"/>
-                </a:solidFill>
-                <a:latin typeface="Calibri"/>
-              </a:rPr>
-              <a:t>Adaptive Context Reasoning System — a research programme, not a performance number.</a:t>
-            </a:r>
-          </a:p>
-        </p:txBody>
-      </p:sp>
-      <p:sp>
-        <p:nvSpPr>
-          <p:cNvPr id="12" name="TextBox 11"/>
-          <p:cNvSpPr txBox="1"/>
-          <p:nvPr/>
-        </p:nvSpPr>
-        <p:spPr>
-          <a:xfrm>
-            <a:off x="365760" y="2212848"/>
             <a:ext cx="11430000" cy="3977639"/>
           </a:xfrm>
           <a:prstGeom prst="rect">
@@ -17439,7 +17729,7 @@
                 </a:solidFill>
                 <a:latin typeface="Calibri"/>
               </a:rPr>
-              <a:t>Presented By: Jenisha T</a:t>
+              <a:t>Wu, Q., Bansal, G., Zhang, J., Wu, Y., Li, B., Zhu, E., Jiang, L., Zhang, X., Zhang, S., Liu, J., Awadallah, A. H., White, R. W., Burger, D., and Wang, C. AutoGen: Enabling Next-Gen LLM Applications via Multi-Agent Conversation. ICLR 2024 Workshop on Large Language Model (LLM) Agents; also COLM 2024. arXiv:2308.08155.</a:t>
             </a:r>
           </a:p>
           <a:p>
@@ -17457,7 +17747,7 @@
                 </a:solidFill>
                 <a:latin typeface="Calibri"/>
               </a:rPr>
-              <a:t>(Reg. No. 24ETRP720001)</a:t>
+              <a:t>Hong, S., Zhuge, M., Chen, J., Zheng, X., Cheng, Y., Wang, J., Zhang, C., Wang, Z., Yau, S. K. S., Lin, Z., Zhou, L., Ran, C., Xiao, L., Wu, C., and Schmidhuber, J. MetaGPT: Meta Programming for A Multi-Agent Collaborative Framework. ICLR 2024.</a:t>
             </a:r>
           </a:p>
           <a:p>
@@ -17475,7 +17765,7 @@
                 </a:solidFill>
                 <a:latin typeface="Calibri"/>
               </a:rPr>
-              <a:t>Supervisor: Dr. Jyothi A P</a:t>
+              <a:t>Li, G., Hammoud, H. A. A. K., Itani, H., Khizbullin, D., and Ghanem, B. CAMEL: Communicative Agents for “Mind” Exploration of Large Language Model Society. NeurIPS 2023.</a:t>
             </a:r>
           </a:p>
           <a:p>
@@ -17493,7 +17783,7 @@
                 </a:solidFill>
                 <a:latin typeface="Calibri"/>
               </a:rPr>
-              <a:t>Department of Computer Science and Engineering</a:t>
+              <a:t>Qian, C., Liu, W., Liu, H., Chen, N., Dang, Y., Li, J., Yang, C., Chen, W., Su, Y., Cong, X., Xu, J., Li, D., Liu, Z., and Sun, M. ChatDev: Communicative Agents for Software Development. ACL 2024. arXiv:2307.07924.</a:t>
             </a:r>
           </a:p>
           <a:p>
@@ -17511,7 +17801,7 @@
                 </a:solidFill>
                 <a:latin typeface="Calibri"/>
               </a:rPr>
-              <a:t>Faculty of Engineering and Technology, MSRUAS</a:t>
+              <a:t>Qin, Y., Liang, S., Ye, Y., Zhu, K., Yan, L., Lu, Y., Lin, Y., Cong, X., Tang, X., Qian, B., Zhao, S., Hong, L., Tian, R., Xie, R., Zhou, J., Gerstein, M., Li, D., Liu, Z., and Sun, M. ToolLLM: Facilitating Large Language Models to Master 16000+ Real-world APIs. ICLR 2024.</a:t>
             </a:r>
           </a:p>
           <a:p>
@@ -17529,7 +17819,7 @@
                 </a:solidFill>
                 <a:latin typeface="Calibri"/>
               </a:rPr>
-              <a:t>jenisha.t@msruas.ac.in</a:t>
+              <a:t>Zheng, Y., Li, P., Liu, W., Liu, Y., Luan, J., and Wang, B. ToolRerank: Adaptive and Hierarchy-Aware Reranking for Tool Retrieval. LREC-COLING 2024.</a:t>
             </a:r>
           </a:p>
         </p:txBody>
@@ -17555,7 +17845,7 @@
           <a:lstStyle/>
           <a:p>
             <a:pPr algn="l"/>
-            <a:fld id="{a788b296-e162-4685-9fd6-45ec38f2277f}" type="datetime3">
+            <a:fld id="{9cdb6dfa-da93-495b-a150-a5d82e7710de}" type="datetime3">
               <a:rPr lang="en-GB" sz="1000" dirty="0">
                 <a:solidFill>
                   <a:srgbClr val="C4A35A"/>
@@ -17589,7 +17879,7 @@
           <a:lstStyle/>
           <a:p>
             <a:pPr algn="r"/>
-            <a:fld id="{8304211e-782d-4da2-9fa0-25738d4dad1d}" type="slidenum">
+            <a:fld id="{81fa6b54-347d-4f02-bd8c-3c1541a1f152}" type="slidenum">
               <a:rPr lang="en-GB" sz="1000" dirty="0">
                 <a:solidFill>
                   <a:srgbClr val="C4A35A"/>
@@ -17605,7 +17895,1835 @@
                 </a:solidFill>
                 <a:latin typeface="Calibri"/>
               </a:rPr>
-              <a:t> / 26</a:t>
+              <a:t> / 29</a:t>
+            </a:r>
+            <a:endParaRPr lang="en-GB" sz="1000"/>
+          </a:p>
+        </p:txBody>
+      </p:sp>
+    </p:spTree>
+  </p:cSld>
+  <p:clrMapOvr>
+    <a:masterClrMapping/>
+  </p:clrMapOvr>
+  <p:hf sldNum="1" hdr="0" ftr="1" dt="1"/>
+</p:sld>
+</file>
+
+<file path=ppt/slides/slide27.xml><?xml version="1.0" encoding="utf-8"?>
+<p:sld xmlns:a="http://schemas.openxmlformats.org/drawingml/2006/main" xmlns:p="http://schemas.openxmlformats.org/presentationml/2006/main" xmlns:r="http://schemas.openxmlformats.org/officeDocument/2006/relationships">
+  <p:cSld>
+    <p:spTree>
+      <p:nvGrpSpPr>
+        <p:cNvPr id="1" name=""/>
+        <p:cNvGrpSpPr/>
+        <p:nvPr/>
+      </p:nvGrpSpPr>
+      <p:grpSpPr/>
+      <p:sp>
+        <p:nvSpPr>
+          <p:cNvPr id="2" name="Rectangle 1"/>
+          <p:cNvSpPr/>
+          <p:nvPr/>
+        </p:nvSpPr>
+        <p:spPr>
+          <a:xfrm>
+            <a:off x="0" y="0"/>
+            <a:ext cx="12191695" cy="658368"/>
+          </a:xfrm>
+          <a:prstGeom prst="rect">
+            <a:avLst/>
+          </a:prstGeom>
+          <a:solidFill>
+            <a:srgbClr val="7C1D2E"/>
+          </a:solidFill>
+          <a:ln>
+            <a:noFill/>
+          </a:ln>
+        </p:spPr>
+        <p:style>
+          <a:lnRef idx="1">
+            <a:schemeClr val="accent1"/>
+          </a:lnRef>
+          <a:fillRef idx="3">
+            <a:schemeClr val="accent1"/>
+          </a:fillRef>
+          <a:effectRef idx="2">
+            <a:schemeClr val="accent1"/>
+          </a:effectRef>
+          <a:fontRef idx="minor">
+            <a:schemeClr val="lt1"/>
+          </a:fontRef>
+        </p:style>
+        <p:txBody>
+          <a:bodyPr rtlCol="0" anchor="ctr"/>
+          <a:lstStyle/>
+          <a:p>
+            <a:pPr algn="ctr"/>
+          </a:p>
+        </p:txBody>
+      </p:sp>
+      <p:sp>
+        <p:nvSpPr>
+          <p:cNvPr id="3" name="Rectangle 2"/>
+          <p:cNvSpPr/>
+          <p:nvPr/>
+        </p:nvSpPr>
+        <p:spPr>
+          <a:xfrm>
+            <a:off x="0" y="658368"/>
+            <a:ext cx="12191695" cy="54864"/>
+          </a:xfrm>
+          <a:prstGeom prst="rect">
+            <a:avLst/>
+          </a:prstGeom>
+          <a:solidFill>
+            <a:srgbClr val="C4A35A"/>
+          </a:solidFill>
+          <a:ln>
+            <a:noFill/>
+          </a:ln>
+        </p:spPr>
+        <p:style>
+          <a:lnRef idx="1">
+            <a:schemeClr val="accent1"/>
+          </a:lnRef>
+          <a:fillRef idx="3">
+            <a:schemeClr val="accent1"/>
+          </a:fillRef>
+          <a:effectRef idx="2">
+            <a:schemeClr val="accent1"/>
+          </a:effectRef>
+          <a:fontRef idx="minor">
+            <a:schemeClr val="lt1"/>
+          </a:fontRef>
+        </p:style>
+        <p:txBody>
+          <a:bodyPr rtlCol="0" anchor="ctr"/>
+          <a:lstStyle/>
+          <a:p>
+            <a:pPr algn="ctr"/>
+          </a:p>
+        </p:txBody>
+      </p:sp>
+      <p:sp>
+        <p:nvSpPr>
+          <p:cNvPr id="4" name="Rectangle 3"/>
+          <p:cNvSpPr/>
+          <p:nvPr/>
+        </p:nvSpPr>
+        <p:spPr>
+          <a:xfrm>
+            <a:off x="0" y="6510528"/>
+            <a:ext cx="12191695" cy="347472"/>
+          </a:xfrm>
+          <a:prstGeom prst="rect">
+            <a:avLst/>
+          </a:prstGeom>
+          <a:solidFill>
+            <a:srgbClr val="7C1D2E"/>
+          </a:solidFill>
+          <a:ln>
+            <a:noFill/>
+          </a:ln>
+        </p:spPr>
+        <p:style>
+          <a:lnRef idx="1">
+            <a:schemeClr val="accent1"/>
+          </a:lnRef>
+          <a:fillRef idx="3">
+            <a:schemeClr val="accent1"/>
+          </a:fillRef>
+          <a:effectRef idx="2">
+            <a:schemeClr val="accent1"/>
+          </a:effectRef>
+          <a:fontRef idx="minor">
+            <a:schemeClr val="lt1"/>
+          </a:fontRef>
+        </p:style>
+        <p:txBody>
+          <a:bodyPr rtlCol="0" anchor="ctr"/>
+          <a:lstStyle/>
+          <a:p>
+            <a:pPr algn="ctr"/>
+          </a:p>
+        </p:txBody>
+      </p:sp>
+      <p:sp>
+        <p:nvSpPr>
+          <p:cNvPr id="5" name="TextBox 4"/>
+          <p:cNvSpPr txBox="1"/>
+          <p:nvPr/>
+        </p:nvSpPr>
+        <p:spPr>
+          <a:xfrm>
+            <a:off x="292608" y="73152"/>
+            <a:ext cx="11521440" cy="292608"/>
+          </a:xfrm>
+          <a:prstGeom prst="rect">
+            <a:avLst/>
+          </a:prstGeom>
+          <a:noFill/>
+        </p:spPr>
+        <p:txBody>
+          <a:bodyPr wrap="square">
+            <a:spAutoFit/>
+          </a:bodyPr>
+          <a:lstStyle/>
+          <a:p>
+            <a:pPr algn="l"/>
+            <a:r>
+              <a:rPr sz="1300" b="1">
+                <a:solidFill>
+                  <a:srgbClr val="FFFFFF"/>
+                </a:solidFill>
+                <a:latin typeface="Calibri"/>
+              </a:rPr>
+              <a:t>M. S. RAMAIAH UNIVERSITY OF APPLIED SCIENCES</a:t>
+            </a:r>
+          </a:p>
+        </p:txBody>
+      </p:sp>
+      <p:sp>
+        <p:nvSpPr>
+          <p:cNvPr id="6" name="TextBox 5"/>
+          <p:cNvSpPr txBox="1"/>
+          <p:nvPr/>
+        </p:nvSpPr>
+        <p:spPr>
+          <a:xfrm>
+            <a:off x="292608" y="347472"/>
+            <a:ext cx="11521440" cy="256032"/>
+          </a:xfrm>
+          <a:prstGeom prst="rect">
+            <a:avLst/>
+          </a:prstGeom>
+          <a:noFill/>
+        </p:spPr>
+        <p:txBody>
+          <a:bodyPr wrap="square">
+            <a:spAutoFit/>
+          </a:bodyPr>
+          <a:lstStyle/>
+          <a:p>
+            <a:pPr algn="l"/>
+            <a:r>
+              <a:rPr sz="1100" b="0">
+                <a:solidFill>
+                  <a:srgbClr val="C4A35A"/>
+                </a:solidFill>
+                <a:latin typeface="Calibri"/>
+              </a:rPr>
+              <a:t>Faculty of Engineering and Technology  ·  RESEARCH PROPOSAL</a:t>
+            </a:r>
+          </a:p>
+        </p:txBody>
+      </p:sp>
+      <p:sp>
+        <p:nvSpPr>
+          <p:cNvPr id="7" name="TextBox 6"/>
+          <p:cNvSpPr txBox="1"/>
+          <p:nvPr/>
+        </p:nvSpPr>
+        <p:spPr>
+          <a:xfrm>
+            <a:off x="3383280" y="6565392"/>
+            <a:ext cx="5760720" cy="237744"/>
+          </a:xfrm>
+          <a:prstGeom prst="rect">
+            <a:avLst/>
+          </a:prstGeom>
+          <a:noFill/>
+        </p:spPr>
+        <p:txBody>
+          <a:bodyPr wrap="square">
+            <a:spAutoFit/>
+          </a:bodyPr>
+          <a:lstStyle/>
+          <a:p>
+            <a:pPr algn="ctr"/>
+            <a:r>
+              <a:rPr sz="1000" b="0">
+                <a:solidFill>
+                  <a:srgbClr val="FFFFFF"/>
+                </a:solidFill>
+                <a:latin typeface="Calibri"/>
+              </a:rPr>
+              <a:t>Jenisha T  |  24ETRP720001  |  Part Time</a:t>
+            </a:r>
+          </a:p>
+        </p:txBody>
+      </p:sp>
+      <p:sp>
+        <p:nvSpPr>
+          <p:cNvPr id="8" name="Rectangle 7"/>
+          <p:cNvSpPr/>
+          <p:nvPr/>
+        </p:nvSpPr>
+        <p:spPr>
+          <a:xfrm>
+            <a:off x="0" y="713232"/>
+            <a:ext cx="12191695" cy="5797296"/>
+          </a:xfrm>
+          <a:prstGeom prst="rect">
+            <a:avLst/>
+          </a:prstGeom>
+          <a:solidFill>
+            <a:srgbClr val="FFFAF3"/>
+          </a:solidFill>
+          <a:ln>
+            <a:noFill/>
+          </a:ln>
+        </p:spPr>
+        <p:style>
+          <a:lnRef idx="1">
+            <a:schemeClr val="accent1"/>
+          </a:lnRef>
+          <a:fillRef idx="3">
+            <a:schemeClr val="accent1"/>
+          </a:fillRef>
+          <a:effectRef idx="2">
+            <a:schemeClr val="accent1"/>
+          </a:effectRef>
+          <a:fontRef idx="minor">
+            <a:schemeClr val="lt1"/>
+          </a:fontRef>
+        </p:style>
+        <p:txBody>
+          <a:bodyPr rtlCol="0" anchor="ctr"/>
+          <a:lstStyle/>
+          <a:p>
+            <a:pPr algn="ctr"/>
+          </a:p>
+        </p:txBody>
+      </p:sp>
+      <p:sp>
+        <p:nvSpPr>
+          <p:cNvPr id="9" name="TextBox 8"/>
+          <p:cNvSpPr txBox="1"/>
+          <p:nvPr/>
+        </p:nvSpPr>
+        <p:spPr>
+          <a:xfrm>
+            <a:off x="365760" y="804672"/>
+            <a:ext cx="11430000" cy="237744"/>
+          </a:xfrm>
+          <a:prstGeom prst="rect">
+            <a:avLst/>
+          </a:prstGeom>
+          <a:noFill/>
+        </p:spPr>
+        <p:txBody>
+          <a:bodyPr wrap="square">
+            <a:spAutoFit/>
+          </a:bodyPr>
+          <a:lstStyle/>
+          <a:p>
+            <a:pPr algn="l"/>
+            <a:r>
+              <a:rPr sz="1100" b="1">
+                <a:solidFill>
+                  <a:srgbClr val="7C1D2E"/>
+                </a:solidFill>
+                <a:latin typeface="Calibri"/>
+              </a:rPr>
+              <a:t>RESEARCH PROPOSAL  ·  References 2/3</a:t>
+            </a:r>
+          </a:p>
+        </p:txBody>
+      </p:sp>
+      <p:sp>
+        <p:nvSpPr>
+          <p:cNvPr id="10" name="TextBox 9"/>
+          <p:cNvSpPr txBox="1"/>
+          <p:nvPr/>
+        </p:nvSpPr>
+        <p:spPr>
+          <a:xfrm>
+            <a:off x="365760" y="1024128"/>
+            <a:ext cx="11430000" cy="502920"/>
+          </a:xfrm>
+          <a:prstGeom prst="rect">
+            <a:avLst/>
+          </a:prstGeom>
+          <a:noFill/>
+        </p:spPr>
+        <p:txBody>
+          <a:bodyPr wrap="square">
+            <a:spAutoFit/>
+          </a:bodyPr>
+          <a:lstStyle/>
+          <a:p>
+            <a:pPr algn="l"/>
+            <a:r>
+              <a:rPr sz="2200" b="1">
+                <a:solidFill>
+                  <a:srgbClr val="1A1214"/>
+                </a:solidFill>
+                <a:latin typeface="Calibri"/>
+              </a:rPr>
+              <a:t>References (2/3) — routing, compression, reasoning, biology</a:t>
+            </a:r>
+          </a:p>
+        </p:txBody>
+      </p:sp>
+      <p:sp>
+        <p:nvSpPr>
+          <p:cNvPr id="11" name="TextBox 10"/>
+          <p:cNvSpPr txBox="1"/>
+          <p:nvPr/>
+        </p:nvSpPr>
+        <p:spPr>
+          <a:xfrm>
+            <a:off x="365760" y="1572768"/>
+            <a:ext cx="11430000" cy="3977639"/>
+          </a:xfrm>
+          <a:prstGeom prst="rect">
+            <a:avLst/>
+          </a:prstGeom>
+          <a:noFill/>
+        </p:spPr>
+        <p:txBody>
+          <a:bodyPr wrap="square">
+            <a:spAutoFit/>
+          </a:bodyPr>
+          <a:lstStyle/>
+          <a:p>
+            <a:pPr>
+              <a:spcAft>
+                <a:spcPts val="600"/>
+              </a:spcAft>
+              <a:buFont typeface="Arial"/>
+              <a:buChar char="•"/>
+            </a:pPr>
+            <a:r>
+              <a:rPr sz="1300">
+                <a:solidFill>
+                  <a:srgbClr val="1A1214"/>
+                </a:solidFill>
+                <a:latin typeface="Calibri"/>
+              </a:rPr>
+              <a:t>Ong, I., Almahairi, A., Wu, V., Chiang, W.-L., Wu, T., Gonzalez, J. E., Kadous, M. W., and Stoica, I. RouteLLM: Learning to Route LLMs with Preference Data. arXiv:2406.18665, 2024.</a:t>
+            </a:r>
+          </a:p>
+          <a:p>
+            <a:pPr>
+              <a:spcAft>
+                <a:spcPts val="600"/>
+              </a:spcAft>
+              <a:buFont typeface="Arial"/>
+              <a:buChar char="•"/>
+            </a:pPr>
+            <a:r>
+              <a:rPr sz="1300">
+                <a:solidFill>
+                  <a:srgbClr val="1A1214"/>
+                </a:solidFill>
+                <a:latin typeface="Calibri"/>
+              </a:rPr>
+              <a:t>Panda, S., and co-authors. PILOT: Preference-informed LinUCB for routing among language models. Findings of EMNLP 2025.</a:t>
+            </a:r>
+          </a:p>
+          <a:p>
+            <a:pPr>
+              <a:spcAft>
+                <a:spcPts val="600"/>
+              </a:spcAft>
+              <a:buFont typeface="Arial"/>
+              <a:buChar char="•"/>
+            </a:pPr>
+            <a:r>
+              <a:rPr sz="1300">
+                <a:solidFill>
+                  <a:srgbClr val="1A1214"/>
+                </a:solidFill>
+                <a:latin typeface="Calibri"/>
+              </a:rPr>
+              <a:t>Yue, Y., Zhang, G., Liu, B., Wan, G., Wang, K., Cheng, D., and Qi, Y. MasRouter: Learning to Route LLMs for Multi-Agent Systems. ACL 2025 (long). doi:10.18653/v1/2025.acl-long.757.</a:t>
+            </a:r>
+          </a:p>
+          <a:p>
+            <a:pPr>
+              <a:spcAft>
+                <a:spcPts val="600"/>
+              </a:spcAft>
+              <a:buFont typeface="Arial"/>
+              <a:buChar char="•"/>
+            </a:pPr>
+            <a:r>
+              <a:rPr sz="1300">
+                <a:solidFill>
+                  <a:srgbClr val="1A1214"/>
+                </a:solidFill>
+                <a:latin typeface="Calibri"/>
+              </a:rPr>
+              <a:t>Jiang, H., Wu, Q., Lin, C.-Y., Yang, Y., and Qiu, L. LLMLingua: Compressing Prompts for Accelerated Inference of Large Language Models. EMNLP 2023.</a:t>
+            </a:r>
+          </a:p>
+          <a:p>
+            <a:pPr>
+              <a:spcAft>
+                <a:spcPts val="600"/>
+              </a:spcAft>
+              <a:buFont typeface="Arial"/>
+              <a:buChar char="•"/>
+            </a:pPr>
+            <a:r>
+              <a:rPr sz="1300">
+                <a:solidFill>
+                  <a:srgbClr val="1A1214"/>
+                </a:solidFill>
+                <a:latin typeface="Calibri"/>
+              </a:rPr>
+              <a:t>Wei, J., Wang, X., Schuurmans, D., Bosma, M., Ichter, B., Xia, F., Chi, E., Le, Q., and Zhou, D. Chain-of-Thought Prompting Elicits Reasoning in Large Language Models. NeurIPS 2022.</a:t>
+            </a:r>
+          </a:p>
+          <a:p>
+            <a:pPr>
+              <a:spcAft>
+                <a:spcPts val="600"/>
+              </a:spcAft>
+              <a:buFont typeface="Arial"/>
+              <a:buChar char="•"/>
+            </a:pPr>
+            <a:r>
+              <a:rPr sz="1300">
+                <a:solidFill>
+                  <a:srgbClr val="1A1214"/>
+                </a:solidFill>
+                <a:latin typeface="Calibri"/>
+              </a:rPr>
+              <a:t>Yao, S., Zhao, J., Yu, D., Du, N., Shafran, I., Narasimhan, K., and Cao, Y. ReAct: Synergizing Reasoning and Acting in Language Models. ICLR 2023.</a:t>
+            </a:r>
+          </a:p>
+          <a:p>
+            <a:pPr>
+              <a:spcAft>
+                <a:spcPts val="600"/>
+              </a:spcAft>
+              <a:buFont typeface="Arial"/>
+              <a:buChar char="•"/>
+            </a:pPr>
+            <a:r>
+              <a:rPr sz="1300">
+                <a:solidFill>
+                  <a:srgbClr val="1A1214"/>
+                </a:solidFill>
+                <a:latin typeface="Calibri"/>
+              </a:rPr>
+              <a:t>Yao, S., Yu, D., Zhao, J., Shafran, I., Griffiths, T. L., Cao, Y., and Narasimhan, K. Tree of Thoughts: Deliberate Problem Solving with Large Language Models. NeurIPS 2023.</a:t>
+            </a:r>
+          </a:p>
+          <a:p>
+            <a:pPr>
+              <a:spcAft>
+                <a:spcPts val="600"/>
+              </a:spcAft>
+              <a:buFont typeface="Arial"/>
+              <a:buChar char="•"/>
+            </a:pPr>
+            <a:r>
+              <a:rPr sz="1300">
+                <a:solidFill>
+                  <a:srgbClr val="1A1214"/>
+                </a:solidFill>
+                <a:latin typeface="Calibri"/>
+              </a:rPr>
+              <a:t>Tero, A., Takagi, S., Saigusa, T., Ito, K., Bebber, D. P., Fricker, M. D., Yumiki, K., Kobayashi, R., and Nakagaki, T. Rules for Biologically Inspired Adaptive Network Design. Science, 2010. doi:10.1126/science.1177894.</a:t>
+            </a:r>
+          </a:p>
+        </p:txBody>
+      </p:sp>
+      <p:sp>
+        <p:nvSpPr>
+          <p:cNvPr id="4027" name="Automatic Date 27"/>
+          <p:cNvSpPr txBox="1"/>
+          <p:nvPr/>
+        </p:nvSpPr>
+        <p:spPr>
+          <a:xfrm>
+            <a:off x="255016" y="6565900"/>
+            <a:ext cx="3108960" cy="255016"/>
+          </a:xfrm>
+          <a:prstGeom prst="rect">
+            <a:avLst/>
+          </a:prstGeom>
+          <a:noFill/>
+        </p:spPr>
+        <p:txBody>
+          <a:bodyPr wrap="none" lIns="0" tIns="0" rIns="0" bIns="0" anchor="ctr"/>
+          <a:lstStyle/>
+          <a:p>
+            <a:pPr algn="l"/>
+            <a:fld id="{562959d6-ef5e-4a9e-af27-b616b9d5d687}" type="datetime3">
+              <a:rPr lang="en-GB" sz="1000" dirty="0">
+                <a:solidFill>
+                  <a:srgbClr val="C4A35A"/>
+                </a:solidFill>
+                <a:latin typeface="Calibri"/>
+              </a:rPr>
+              <a:t>7 September 2026</a:t>
+            </a:fld>
+            <a:endParaRPr lang="en-GB" sz="1000"/>
+          </a:p>
+        </p:txBody>
+      </p:sp>
+      <p:sp>
+        <p:nvSpPr>
+          <p:cNvPr id="5027" name="Automatic Slide Number 27"/>
+          <p:cNvSpPr txBox="1"/>
+          <p:nvPr/>
+        </p:nvSpPr>
+        <p:spPr>
+          <a:xfrm>
+            <a:off x="9601200" y="6565900"/>
+            <a:ext cx="2286000" cy="255016"/>
+          </a:xfrm>
+          <a:prstGeom prst="rect">
+            <a:avLst/>
+          </a:prstGeom>
+          <a:noFill/>
+        </p:spPr>
+        <p:txBody>
+          <a:bodyPr wrap="none" lIns="0" tIns="0" rIns="0" bIns="0" anchor="ctr"/>
+          <a:lstStyle/>
+          <a:p>
+            <a:pPr algn="r"/>
+            <a:fld id="{d83c6a4c-5d4d-4e13-9e3e-6fce3b0005ec}" type="slidenum">
+              <a:rPr lang="en-GB" sz="1000" dirty="0">
+                <a:solidFill>
+                  <a:srgbClr val="C4A35A"/>
+                </a:solidFill>
+                <a:latin typeface="Calibri"/>
+              </a:rPr>
+              <a:t>27</a:t>
+            </a:fld>
+            <a:r>
+              <a:rPr lang="en-GB" sz="1000">
+                <a:solidFill>
+                  <a:srgbClr val="C4A35A"/>
+                </a:solidFill>
+                <a:latin typeface="Calibri"/>
+              </a:rPr>
+              <a:t> / 29</a:t>
+            </a:r>
+            <a:endParaRPr lang="en-GB" sz="1000"/>
+          </a:p>
+        </p:txBody>
+      </p:sp>
+    </p:spTree>
+  </p:cSld>
+  <p:clrMapOvr>
+    <a:masterClrMapping/>
+  </p:clrMapOvr>
+  <p:hf sldNum="1" hdr="0" ftr="1" dt="1"/>
+</p:sld>
+</file>
+
+<file path=ppt/slides/slide28.xml><?xml version="1.0" encoding="utf-8"?>
+<p:sld xmlns:a="http://schemas.openxmlformats.org/drawingml/2006/main" xmlns:p="http://schemas.openxmlformats.org/presentationml/2006/main" xmlns:r="http://schemas.openxmlformats.org/officeDocument/2006/relationships">
+  <p:cSld>
+    <p:spTree>
+      <p:nvGrpSpPr>
+        <p:cNvPr id="1" name=""/>
+        <p:cNvGrpSpPr/>
+        <p:nvPr/>
+      </p:nvGrpSpPr>
+      <p:grpSpPr/>
+      <p:sp>
+        <p:nvSpPr>
+          <p:cNvPr id="2" name="Rectangle 1"/>
+          <p:cNvSpPr/>
+          <p:nvPr/>
+        </p:nvSpPr>
+        <p:spPr>
+          <a:xfrm>
+            <a:off x="0" y="0"/>
+            <a:ext cx="12191695" cy="658368"/>
+          </a:xfrm>
+          <a:prstGeom prst="rect">
+            <a:avLst/>
+          </a:prstGeom>
+          <a:solidFill>
+            <a:srgbClr val="7C1D2E"/>
+          </a:solidFill>
+          <a:ln>
+            <a:noFill/>
+          </a:ln>
+        </p:spPr>
+        <p:style>
+          <a:lnRef idx="1">
+            <a:schemeClr val="accent1"/>
+          </a:lnRef>
+          <a:fillRef idx="3">
+            <a:schemeClr val="accent1"/>
+          </a:fillRef>
+          <a:effectRef idx="2">
+            <a:schemeClr val="accent1"/>
+          </a:effectRef>
+          <a:fontRef idx="minor">
+            <a:schemeClr val="lt1"/>
+          </a:fontRef>
+        </p:style>
+        <p:txBody>
+          <a:bodyPr rtlCol="0" anchor="ctr"/>
+          <a:lstStyle/>
+          <a:p>
+            <a:pPr algn="ctr"/>
+          </a:p>
+        </p:txBody>
+      </p:sp>
+      <p:sp>
+        <p:nvSpPr>
+          <p:cNvPr id="3" name="Rectangle 2"/>
+          <p:cNvSpPr/>
+          <p:nvPr/>
+        </p:nvSpPr>
+        <p:spPr>
+          <a:xfrm>
+            <a:off x="0" y="658368"/>
+            <a:ext cx="12191695" cy="54864"/>
+          </a:xfrm>
+          <a:prstGeom prst="rect">
+            <a:avLst/>
+          </a:prstGeom>
+          <a:solidFill>
+            <a:srgbClr val="C4A35A"/>
+          </a:solidFill>
+          <a:ln>
+            <a:noFill/>
+          </a:ln>
+        </p:spPr>
+        <p:style>
+          <a:lnRef idx="1">
+            <a:schemeClr val="accent1"/>
+          </a:lnRef>
+          <a:fillRef idx="3">
+            <a:schemeClr val="accent1"/>
+          </a:fillRef>
+          <a:effectRef idx="2">
+            <a:schemeClr val="accent1"/>
+          </a:effectRef>
+          <a:fontRef idx="minor">
+            <a:schemeClr val="lt1"/>
+          </a:fontRef>
+        </p:style>
+        <p:txBody>
+          <a:bodyPr rtlCol="0" anchor="ctr"/>
+          <a:lstStyle/>
+          <a:p>
+            <a:pPr algn="ctr"/>
+          </a:p>
+        </p:txBody>
+      </p:sp>
+      <p:sp>
+        <p:nvSpPr>
+          <p:cNvPr id="4" name="Rectangle 3"/>
+          <p:cNvSpPr/>
+          <p:nvPr/>
+        </p:nvSpPr>
+        <p:spPr>
+          <a:xfrm>
+            <a:off x="0" y="6510528"/>
+            <a:ext cx="12191695" cy="347472"/>
+          </a:xfrm>
+          <a:prstGeom prst="rect">
+            <a:avLst/>
+          </a:prstGeom>
+          <a:solidFill>
+            <a:srgbClr val="7C1D2E"/>
+          </a:solidFill>
+          <a:ln>
+            <a:noFill/>
+          </a:ln>
+        </p:spPr>
+        <p:style>
+          <a:lnRef idx="1">
+            <a:schemeClr val="accent1"/>
+          </a:lnRef>
+          <a:fillRef idx="3">
+            <a:schemeClr val="accent1"/>
+          </a:fillRef>
+          <a:effectRef idx="2">
+            <a:schemeClr val="accent1"/>
+          </a:effectRef>
+          <a:fontRef idx="minor">
+            <a:schemeClr val="lt1"/>
+          </a:fontRef>
+        </p:style>
+        <p:txBody>
+          <a:bodyPr rtlCol="0" anchor="ctr"/>
+          <a:lstStyle/>
+          <a:p>
+            <a:pPr algn="ctr"/>
+          </a:p>
+        </p:txBody>
+      </p:sp>
+      <p:sp>
+        <p:nvSpPr>
+          <p:cNvPr id="5" name="TextBox 4"/>
+          <p:cNvSpPr txBox="1"/>
+          <p:nvPr/>
+        </p:nvSpPr>
+        <p:spPr>
+          <a:xfrm>
+            <a:off x="292608" y="73152"/>
+            <a:ext cx="11521440" cy="292608"/>
+          </a:xfrm>
+          <a:prstGeom prst="rect">
+            <a:avLst/>
+          </a:prstGeom>
+          <a:noFill/>
+        </p:spPr>
+        <p:txBody>
+          <a:bodyPr wrap="square">
+            <a:spAutoFit/>
+          </a:bodyPr>
+          <a:lstStyle/>
+          <a:p>
+            <a:pPr algn="l"/>
+            <a:r>
+              <a:rPr sz="1300" b="1">
+                <a:solidFill>
+                  <a:srgbClr val="FFFFFF"/>
+                </a:solidFill>
+                <a:latin typeface="Calibri"/>
+              </a:rPr>
+              <a:t>M. S. RAMAIAH UNIVERSITY OF APPLIED SCIENCES</a:t>
+            </a:r>
+          </a:p>
+        </p:txBody>
+      </p:sp>
+      <p:sp>
+        <p:nvSpPr>
+          <p:cNvPr id="6" name="TextBox 5"/>
+          <p:cNvSpPr txBox="1"/>
+          <p:nvPr/>
+        </p:nvSpPr>
+        <p:spPr>
+          <a:xfrm>
+            <a:off x="292608" y="347472"/>
+            <a:ext cx="11521440" cy="256032"/>
+          </a:xfrm>
+          <a:prstGeom prst="rect">
+            <a:avLst/>
+          </a:prstGeom>
+          <a:noFill/>
+        </p:spPr>
+        <p:txBody>
+          <a:bodyPr wrap="square">
+            <a:spAutoFit/>
+          </a:bodyPr>
+          <a:lstStyle/>
+          <a:p>
+            <a:pPr algn="l"/>
+            <a:r>
+              <a:rPr sz="1100" b="0">
+                <a:solidFill>
+                  <a:srgbClr val="C4A35A"/>
+                </a:solidFill>
+                <a:latin typeface="Calibri"/>
+              </a:rPr>
+              <a:t>Faculty of Engineering and Technology  ·  RESEARCH PROPOSAL</a:t>
+            </a:r>
+          </a:p>
+        </p:txBody>
+      </p:sp>
+      <p:sp>
+        <p:nvSpPr>
+          <p:cNvPr id="7" name="TextBox 6"/>
+          <p:cNvSpPr txBox="1"/>
+          <p:nvPr/>
+        </p:nvSpPr>
+        <p:spPr>
+          <a:xfrm>
+            <a:off x="3383280" y="6565392"/>
+            <a:ext cx="5760720" cy="237744"/>
+          </a:xfrm>
+          <a:prstGeom prst="rect">
+            <a:avLst/>
+          </a:prstGeom>
+          <a:noFill/>
+        </p:spPr>
+        <p:txBody>
+          <a:bodyPr wrap="square">
+            <a:spAutoFit/>
+          </a:bodyPr>
+          <a:lstStyle/>
+          <a:p>
+            <a:pPr algn="ctr"/>
+            <a:r>
+              <a:rPr sz="1000" b="0">
+                <a:solidFill>
+                  <a:srgbClr val="FFFFFF"/>
+                </a:solidFill>
+                <a:latin typeface="Calibri"/>
+              </a:rPr>
+              <a:t>Jenisha T  |  24ETRP720001  |  Part Time</a:t>
+            </a:r>
+          </a:p>
+        </p:txBody>
+      </p:sp>
+      <p:sp>
+        <p:nvSpPr>
+          <p:cNvPr id="8" name="Rectangle 7"/>
+          <p:cNvSpPr/>
+          <p:nvPr/>
+        </p:nvSpPr>
+        <p:spPr>
+          <a:xfrm>
+            <a:off x="0" y="713232"/>
+            <a:ext cx="12191695" cy="5797296"/>
+          </a:xfrm>
+          <a:prstGeom prst="rect">
+            <a:avLst/>
+          </a:prstGeom>
+          <a:solidFill>
+            <a:srgbClr val="FFFAF3"/>
+          </a:solidFill>
+          <a:ln>
+            <a:noFill/>
+          </a:ln>
+        </p:spPr>
+        <p:style>
+          <a:lnRef idx="1">
+            <a:schemeClr val="accent1"/>
+          </a:lnRef>
+          <a:fillRef idx="3">
+            <a:schemeClr val="accent1"/>
+          </a:fillRef>
+          <a:effectRef idx="2">
+            <a:schemeClr val="accent1"/>
+          </a:effectRef>
+          <a:fontRef idx="minor">
+            <a:schemeClr val="lt1"/>
+          </a:fontRef>
+        </p:style>
+        <p:txBody>
+          <a:bodyPr rtlCol="0" anchor="ctr"/>
+          <a:lstStyle/>
+          <a:p>
+            <a:pPr algn="ctr"/>
+          </a:p>
+        </p:txBody>
+      </p:sp>
+      <p:sp>
+        <p:nvSpPr>
+          <p:cNvPr id="9" name="TextBox 8"/>
+          <p:cNvSpPr txBox="1"/>
+          <p:nvPr/>
+        </p:nvSpPr>
+        <p:spPr>
+          <a:xfrm>
+            <a:off x="365760" y="804672"/>
+            <a:ext cx="11430000" cy="237744"/>
+          </a:xfrm>
+          <a:prstGeom prst="rect">
+            <a:avLst/>
+          </a:prstGeom>
+          <a:noFill/>
+        </p:spPr>
+        <p:txBody>
+          <a:bodyPr wrap="square">
+            <a:spAutoFit/>
+          </a:bodyPr>
+          <a:lstStyle/>
+          <a:p>
+            <a:pPr algn="l"/>
+            <a:r>
+              <a:rPr sz="1100" b="1">
+                <a:solidFill>
+                  <a:srgbClr val="7C1D2E"/>
+                </a:solidFill>
+                <a:latin typeface="Calibri"/>
+              </a:rPr>
+              <a:t>RESEARCH PROPOSAL  ·  References 3/3</a:t>
+            </a:r>
+          </a:p>
+        </p:txBody>
+      </p:sp>
+      <p:sp>
+        <p:nvSpPr>
+          <p:cNvPr id="10" name="TextBox 9"/>
+          <p:cNvSpPr txBox="1"/>
+          <p:nvPr/>
+        </p:nvSpPr>
+        <p:spPr>
+          <a:xfrm>
+            <a:off x="365760" y="1024128"/>
+            <a:ext cx="11430000" cy="502920"/>
+          </a:xfrm>
+          <a:prstGeom prst="rect">
+            <a:avLst/>
+          </a:prstGeom>
+          <a:noFill/>
+        </p:spPr>
+        <p:txBody>
+          <a:bodyPr wrap="square">
+            <a:spAutoFit/>
+          </a:bodyPr>
+          <a:lstStyle/>
+          <a:p>
+            <a:pPr algn="l"/>
+            <a:r>
+              <a:rPr sz="2200" b="1">
+                <a:solidFill>
+                  <a:srgbClr val="1A1214"/>
+                </a:solidFill>
+                <a:latin typeface="Calibri"/>
+              </a:rPr>
+              <a:t>References (3/3) — memory, tools, Indian agricultural data</a:t>
+            </a:r>
+          </a:p>
+        </p:txBody>
+      </p:sp>
+      <p:sp>
+        <p:nvSpPr>
+          <p:cNvPr id="11" name="TextBox 10"/>
+          <p:cNvSpPr txBox="1"/>
+          <p:nvPr/>
+        </p:nvSpPr>
+        <p:spPr>
+          <a:xfrm>
+            <a:off x="365760" y="1572768"/>
+            <a:ext cx="11430000" cy="3977639"/>
+          </a:xfrm>
+          <a:prstGeom prst="rect">
+            <a:avLst/>
+          </a:prstGeom>
+          <a:noFill/>
+        </p:spPr>
+        <p:txBody>
+          <a:bodyPr wrap="square">
+            <a:spAutoFit/>
+          </a:bodyPr>
+          <a:lstStyle/>
+          <a:p>
+            <a:pPr>
+              <a:spcAft>
+                <a:spcPts val="600"/>
+              </a:spcAft>
+              <a:buFont typeface="Arial"/>
+              <a:buChar char="•"/>
+            </a:pPr>
+            <a:r>
+              <a:rPr sz="1300">
+                <a:solidFill>
+                  <a:srgbClr val="1A1214"/>
+                </a:solidFill>
+                <a:latin typeface="Calibri"/>
+              </a:rPr>
+              <a:t>Park, J. S., O’Brien, J. C., Cai, C. J., Morris, M. R., Liang, P., and Bernstein, M. S. Generative Agents: Interactive Simulacra of Human Behavior. CHI 2023.</a:t>
+            </a:r>
+          </a:p>
+          <a:p>
+            <a:pPr>
+              <a:spcAft>
+                <a:spcPts val="600"/>
+              </a:spcAft>
+              <a:buFont typeface="Arial"/>
+              <a:buChar char="•"/>
+            </a:pPr>
+            <a:r>
+              <a:rPr sz="1300">
+                <a:solidFill>
+                  <a:srgbClr val="1A1214"/>
+                </a:solidFill>
+                <a:latin typeface="Calibri"/>
+              </a:rPr>
+              <a:t>Shinn, N., Cassano, F., Berman, E., Gopinath, A., Narasimhan, K., and Yao, S. Reflexion: Language Agents with Verbal Reinforcement Learning. NeurIPS 2023.</a:t>
+            </a:r>
+          </a:p>
+          <a:p>
+            <a:pPr>
+              <a:spcAft>
+                <a:spcPts val="600"/>
+              </a:spcAft>
+              <a:buFont typeface="Arial"/>
+              <a:buChar char="•"/>
+            </a:pPr>
+            <a:r>
+              <a:rPr sz="1300">
+                <a:solidFill>
+                  <a:srgbClr val="1A1214"/>
+                </a:solidFill>
+                <a:latin typeface="Calibri"/>
+              </a:rPr>
+              <a:t>Shen, Y., Song, K., Tan, X., Li, D., Lu, W., and Zhuang, Y. HuggingGPT: Solving AI Tasks with ChatGPT and its Friends in Hugging Face. NeurIPS 2023.</a:t>
+            </a:r>
+          </a:p>
+          <a:p>
+            <a:pPr>
+              <a:spcAft>
+                <a:spcPts val="600"/>
+              </a:spcAft>
+              <a:buFont typeface="Arial"/>
+              <a:buChar char="•"/>
+            </a:pPr>
+            <a:r>
+              <a:rPr sz="1300">
+                <a:solidFill>
+                  <a:srgbClr val="1A1214"/>
+                </a:solidFill>
+                <a:latin typeface="Calibri"/>
+              </a:rPr>
+              <a:t>Schick, T., Dwivedi-Yu, J., Dessì, R., Raileanu, R., Lomeli, M., Zettlemoyer, L., Cancedda, N., and Scialom, T. Toolformer: Language Models Can Teach Themselves to Use Tools. NeurIPS 2023.</a:t>
+            </a:r>
+          </a:p>
+          <a:p>
+            <a:pPr>
+              <a:spcAft>
+                <a:spcPts val="600"/>
+              </a:spcAft>
+              <a:buFont typeface="Arial"/>
+              <a:buChar char="•"/>
+            </a:pPr>
+            <a:r>
+              <a:rPr sz="1300">
+                <a:solidFill>
+                  <a:srgbClr val="1A1214"/>
+                </a:solidFill>
+                <a:latin typeface="Calibri"/>
+              </a:rPr>
+              <a:t>Guo, H., Woodruff, A., and Yadav, A. Improving Lives of Indebted Farmers Using Deep Learning: Predicting Agricultural Produce Prices Using Convolutional Neural Networks (PECAD). AAAI 2020. doi:10.1609/aaai.v34i08.7039. AGMARKNET scrape for price prediction; cited here as Indian OGD precedent, not as a baseline this proposal claims to beat.</a:t>
+            </a:r>
+          </a:p>
+          <a:p>
+            <a:pPr>
+              <a:spcAft>
+                <a:spcPts val="600"/>
+              </a:spcAft>
+              <a:buFont typeface="Arial"/>
+              <a:buChar char="•"/>
+            </a:pPr>
+            <a:r>
+              <a:rPr sz="1300">
+                <a:solidFill>
+                  <a:srgbClr val="1A1214"/>
+                </a:solidFill>
+                <a:latin typeface="Calibri"/>
+              </a:rPr>
+              <a:t>Government of India. Open Government Data Platform India (data.gov.in); AGMARKNET resource 9ef84268-d588-465a-a308-a864a43d0070; Directorate of Economics and Statistics crop production; IMD rainfall series; Government Open Data License — India (GODL-India).</a:t>
+            </a:r>
+          </a:p>
+        </p:txBody>
+      </p:sp>
+      <p:sp>
+        <p:nvSpPr>
+          <p:cNvPr id="12" name="TextBox 11"/>
+          <p:cNvSpPr txBox="1"/>
+          <p:nvPr/>
+        </p:nvSpPr>
+        <p:spPr>
+          <a:xfrm>
+            <a:off x="365760" y="6199632"/>
+            <a:ext cx="11430000" cy="256032"/>
+          </a:xfrm>
+          <a:prstGeom prst="rect">
+            <a:avLst/>
+          </a:prstGeom>
+          <a:noFill/>
+        </p:spPr>
+        <p:txBody>
+          <a:bodyPr wrap="square">
+            <a:spAutoFit/>
+          </a:bodyPr>
+          <a:lstStyle/>
+          <a:p>
+            <a:pPr algn="l"/>
+            <a:r>
+              <a:rPr sz="1000" b="0">
+                <a:solidFill>
+                  <a:srgbClr val="5C4A4E"/>
+                </a:solidFill>
+                <a:latin typeface="Calibri"/>
+              </a:rPr>
+              <a:t>CrewAI is an engineering framework without a flagship peer-reviewed paper in this list; AutoGen and MetaGPT are the MAS citations.</a:t>
+            </a:r>
+          </a:p>
+        </p:txBody>
+      </p:sp>
+      <p:sp>
+        <p:nvSpPr>
+          <p:cNvPr id="4028" name="Automatic Date 28"/>
+          <p:cNvSpPr txBox="1"/>
+          <p:nvPr/>
+        </p:nvSpPr>
+        <p:spPr>
+          <a:xfrm>
+            <a:off x="255016" y="6565900"/>
+            <a:ext cx="3108960" cy="255016"/>
+          </a:xfrm>
+          <a:prstGeom prst="rect">
+            <a:avLst/>
+          </a:prstGeom>
+          <a:noFill/>
+        </p:spPr>
+        <p:txBody>
+          <a:bodyPr wrap="none" lIns="0" tIns="0" rIns="0" bIns="0" anchor="ctr"/>
+          <a:lstStyle/>
+          <a:p>
+            <a:pPr algn="l"/>
+            <a:fld id="{95b8df89-af37-4df7-8146-f0d9e9d8bae4}" type="datetime3">
+              <a:rPr lang="en-GB" sz="1000" dirty="0">
+                <a:solidFill>
+                  <a:srgbClr val="C4A35A"/>
+                </a:solidFill>
+                <a:latin typeface="Calibri"/>
+              </a:rPr>
+              <a:t>7 September 2026</a:t>
+            </a:fld>
+            <a:endParaRPr lang="en-GB" sz="1000"/>
+          </a:p>
+        </p:txBody>
+      </p:sp>
+      <p:sp>
+        <p:nvSpPr>
+          <p:cNvPr id="5028" name="Automatic Slide Number 28"/>
+          <p:cNvSpPr txBox="1"/>
+          <p:nvPr/>
+        </p:nvSpPr>
+        <p:spPr>
+          <a:xfrm>
+            <a:off x="9601200" y="6565900"/>
+            <a:ext cx="2286000" cy="255016"/>
+          </a:xfrm>
+          <a:prstGeom prst="rect">
+            <a:avLst/>
+          </a:prstGeom>
+          <a:noFill/>
+        </p:spPr>
+        <p:txBody>
+          <a:bodyPr wrap="none" lIns="0" tIns="0" rIns="0" bIns="0" anchor="ctr"/>
+          <a:lstStyle/>
+          <a:p>
+            <a:pPr algn="r"/>
+            <a:fld id="{cb08ca71-0ebf-4857-8a68-891e08413128}" type="slidenum">
+              <a:rPr lang="en-GB" sz="1000" dirty="0">
+                <a:solidFill>
+                  <a:srgbClr val="C4A35A"/>
+                </a:solidFill>
+                <a:latin typeface="Calibri"/>
+              </a:rPr>
+              <a:t>28</a:t>
+            </a:fld>
+            <a:r>
+              <a:rPr lang="en-GB" sz="1000">
+                <a:solidFill>
+                  <a:srgbClr val="C4A35A"/>
+                </a:solidFill>
+                <a:latin typeface="Calibri"/>
+              </a:rPr>
+              <a:t> / 29</a:t>
+            </a:r>
+            <a:endParaRPr lang="en-GB" sz="1000"/>
+          </a:p>
+        </p:txBody>
+      </p:sp>
+    </p:spTree>
+  </p:cSld>
+  <p:clrMapOvr>
+    <a:masterClrMapping/>
+  </p:clrMapOvr>
+  <p:hf sldNum="1" hdr="0" ftr="1" dt="1"/>
+</p:sld>
+</file>
+
+<file path=ppt/slides/slide29.xml><?xml version="1.0" encoding="utf-8"?>
+<p:sld xmlns:a="http://schemas.openxmlformats.org/drawingml/2006/main" xmlns:p="http://schemas.openxmlformats.org/presentationml/2006/main" xmlns:r="http://schemas.openxmlformats.org/officeDocument/2006/relationships">
+  <p:cSld>
+    <p:spTree>
+      <p:nvGrpSpPr>
+        <p:cNvPr id="1" name=""/>
+        <p:cNvGrpSpPr/>
+        <p:nvPr/>
+      </p:nvGrpSpPr>
+      <p:grpSpPr/>
+      <p:sp>
+        <p:nvSpPr>
+          <p:cNvPr id="2" name="Rectangle 1"/>
+          <p:cNvSpPr/>
+          <p:nvPr/>
+        </p:nvSpPr>
+        <p:spPr>
+          <a:xfrm>
+            <a:off x="0" y="0"/>
+            <a:ext cx="12191695" cy="658368"/>
+          </a:xfrm>
+          <a:prstGeom prst="rect">
+            <a:avLst/>
+          </a:prstGeom>
+          <a:solidFill>
+            <a:srgbClr val="7C1D2E"/>
+          </a:solidFill>
+          <a:ln>
+            <a:noFill/>
+          </a:ln>
+        </p:spPr>
+        <p:style>
+          <a:lnRef idx="1">
+            <a:schemeClr val="accent1"/>
+          </a:lnRef>
+          <a:fillRef idx="3">
+            <a:schemeClr val="accent1"/>
+          </a:fillRef>
+          <a:effectRef idx="2">
+            <a:schemeClr val="accent1"/>
+          </a:effectRef>
+          <a:fontRef idx="minor">
+            <a:schemeClr val="lt1"/>
+          </a:fontRef>
+        </p:style>
+        <p:txBody>
+          <a:bodyPr rtlCol="0" anchor="ctr"/>
+          <a:lstStyle/>
+          <a:p>
+            <a:pPr algn="ctr"/>
+          </a:p>
+        </p:txBody>
+      </p:sp>
+      <p:sp>
+        <p:nvSpPr>
+          <p:cNvPr id="3" name="Rectangle 2"/>
+          <p:cNvSpPr/>
+          <p:nvPr/>
+        </p:nvSpPr>
+        <p:spPr>
+          <a:xfrm>
+            <a:off x="0" y="658368"/>
+            <a:ext cx="12191695" cy="54864"/>
+          </a:xfrm>
+          <a:prstGeom prst="rect">
+            <a:avLst/>
+          </a:prstGeom>
+          <a:solidFill>
+            <a:srgbClr val="C4A35A"/>
+          </a:solidFill>
+          <a:ln>
+            <a:noFill/>
+          </a:ln>
+        </p:spPr>
+        <p:style>
+          <a:lnRef idx="1">
+            <a:schemeClr val="accent1"/>
+          </a:lnRef>
+          <a:fillRef idx="3">
+            <a:schemeClr val="accent1"/>
+          </a:fillRef>
+          <a:effectRef idx="2">
+            <a:schemeClr val="accent1"/>
+          </a:effectRef>
+          <a:fontRef idx="minor">
+            <a:schemeClr val="lt1"/>
+          </a:fontRef>
+        </p:style>
+        <p:txBody>
+          <a:bodyPr rtlCol="0" anchor="ctr"/>
+          <a:lstStyle/>
+          <a:p>
+            <a:pPr algn="ctr"/>
+          </a:p>
+        </p:txBody>
+      </p:sp>
+      <p:sp>
+        <p:nvSpPr>
+          <p:cNvPr id="4" name="Rectangle 3"/>
+          <p:cNvSpPr/>
+          <p:nvPr/>
+        </p:nvSpPr>
+        <p:spPr>
+          <a:xfrm>
+            <a:off x="0" y="6510528"/>
+            <a:ext cx="12191695" cy="347472"/>
+          </a:xfrm>
+          <a:prstGeom prst="rect">
+            <a:avLst/>
+          </a:prstGeom>
+          <a:solidFill>
+            <a:srgbClr val="7C1D2E"/>
+          </a:solidFill>
+          <a:ln>
+            <a:noFill/>
+          </a:ln>
+        </p:spPr>
+        <p:style>
+          <a:lnRef idx="1">
+            <a:schemeClr val="accent1"/>
+          </a:lnRef>
+          <a:fillRef idx="3">
+            <a:schemeClr val="accent1"/>
+          </a:fillRef>
+          <a:effectRef idx="2">
+            <a:schemeClr val="accent1"/>
+          </a:effectRef>
+          <a:fontRef idx="minor">
+            <a:schemeClr val="lt1"/>
+          </a:fontRef>
+        </p:style>
+        <p:txBody>
+          <a:bodyPr rtlCol="0" anchor="ctr"/>
+          <a:lstStyle/>
+          <a:p>
+            <a:pPr algn="ctr"/>
+          </a:p>
+        </p:txBody>
+      </p:sp>
+      <p:sp>
+        <p:nvSpPr>
+          <p:cNvPr id="5" name="TextBox 4"/>
+          <p:cNvSpPr txBox="1"/>
+          <p:nvPr/>
+        </p:nvSpPr>
+        <p:spPr>
+          <a:xfrm>
+            <a:off x="292608" y="73152"/>
+            <a:ext cx="11521440" cy="292608"/>
+          </a:xfrm>
+          <a:prstGeom prst="rect">
+            <a:avLst/>
+          </a:prstGeom>
+          <a:noFill/>
+        </p:spPr>
+        <p:txBody>
+          <a:bodyPr wrap="square">
+            <a:spAutoFit/>
+          </a:bodyPr>
+          <a:lstStyle/>
+          <a:p>
+            <a:pPr algn="l"/>
+            <a:r>
+              <a:rPr sz="1300" b="1">
+                <a:solidFill>
+                  <a:srgbClr val="FFFFFF"/>
+                </a:solidFill>
+                <a:latin typeface="Calibri"/>
+              </a:rPr>
+              <a:t>M. S. RAMAIAH UNIVERSITY OF APPLIED SCIENCES</a:t>
+            </a:r>
+          </a:p>
+        </p:txBody>
+      </p:sp>
+      <p:sp>
+        <p:nvSpPr>
+          <p:cNvPr id="6" name="TextBox 5"/>
+          <p:cNvSpPr txBox="1"/>
+          <p:nvPr/>
+        </p:nvSpPr>
+        <p:spPr>
+          <a:xfrm>
+            <a:off x="292608" y="347472"/>
+            <a:ext cx="11521440" cy="256032"/>
+          </a:xfrm>
+          <a:prstGeom prst="rect">
+            <a:avLst/>
+          </a:prstGeom>
+          <a:noFill/>
+        </p:spPr>
+        <p:txBody>
+          <a:bodyPr wrap="square">
+            <a:spAutoFit/>
+          </a:bodyPr>
+          <a:lstStyle/>
+          <a:p>
+            <a:pPr algn="l"/>
+            <a:r>
+              <a:rPr sz="1100" b="0">
+                <a:solidFill>
+                  <a:srgbClr val="C4A35A"/>
+                </a:solidFill>
+                <a:latin typeface="Calibri"/>
+              </a:rPr>
+              <a:t>Faculty of Engineering and Technology  ·  RESEARCH PROPOSAL</a:t>
+            </a:r>
+          </a:p>
+        </p:txBody>
+      </p:sp>
+      <p:sp>
+        <p:nvSpPr>
+          <p:cNvPr id="7" name="TextBox 6"/>
+          <p:cNvSpPr txBox="1"/>
+          <p:nvPr/>
+        </p:nvSpPr>
+        <p:spPr>
+          <a:xfrm>
+            <a:off x="3383280" y="6565392"/>
+            <a:ext cx="5760720" cy="237744"/>
+          </a:xfrm>
+          <a:prstGeom prst="rect">
+            <a:avLst/>
+          </a:prstGeom>
+          <a:noFill/>
+        </p:spPr>
+        <p:txBody>
+          <a:bodyPr wrap="square">
+            <a:spAutoFit/>
+          </a:bodyPr>
+          <a:lstStyle/>
+          <a:p>
+            <a:pPr algn="ctr"/>
+            <a:r>
+              <a:rPr sz="1000" b="0">
+                <a:solidFill>
+                  <a:srgbClr val="FFFFFF"/>
+                </a:solidFill>
+                <a:latin typeface="Calibri"/>
+              </a:rPr>
+              <a:t>Jenisha T  |  24ETRP720001  |  Part Time</a:t>
+            </a:r>
+          </a:p>
+        </p:txBody>
+      </p:sp>
+      <p:sp>
+        <p:nvSpPr>
+          <p:cNvPr id="8" name="Rectangle 7"/>
+          <p:cNvSpPr/>
+          <p:nvPr/>
+        </p:nvSpPr>
+        <p:spPr>
+          <a:xfrm>
+            <a:off x="0" y="713232"/>
+            <a:ext cx="12191695" cy="5797296"/>
+          </a:xfrm>
+          <a:prstGeom prst="rect">
+            <a:avLst/>
+          </a:prstGeom>
+          <a:solidFill>
+            <a:srgbClr val="FFFAF3"/>
+          </a:solidFill>
+          <a:ln>
+            <a:noFill/>
+          </a:ln>
+        </p:spPr>
+        <p:style>
+          <a:lnRef idx="1">
+            <a:schemeClr val="accent1"/>
+          </a:lnRef>
+          <a:fillRef idx="3">
+            <a:schemeClr val="accent1"/>
+          </a:fillRef>
+          <a:effectRef idx="2">
+            <a:schemeClr val="accent1"/>
+          </a:effectRef>
+          <a:fontRef idx="minor">
+            <a:schemeClr val="lt1"/>
+          </a:fontRef>
+        </p:style>
+        <p:txBody>
+          <a:bodyPr rtlCol="0" anchor="ctr"/>
+          <a:lstStyle/>
+          <a:p>
+            <a:pPr algn="ctr"/>
+          </a:p>
+        </p:txBody>
+      </p:sp>
+      <p:sp>
+        <p:nvSpPr>
+          <p:cNvPr id="9" name="TextBox 8"/>
+          <p:cNvSpPr txBox="1"/>
+          <p:nvPr/>
+        </p:nvSpPr>
+        <p:spPr>
+          <a:xfrm>
+            <a:off x="365760" y="804672"/>
+            <a:ext cx="11430000" cy="237744"/>
+          </a:xfrm>
+          <a:prstGeom prst="rect">
+            <a:avLst/>
+          </a:prstGeom>
+          <a:noFill/>
+        </p:spPr>
+        <p:txBody>
+          <a:bodyPr wrap="square">
+            <a:spAutoFit/>
+          </a:bodyPr>
+          <a:lstStyle/>
+          <a:p>
+            <a:pPr algn="l"/>
+            <a:r>
+              <a:rPr sz="1100" b="1">
+                <a:solidFill>
+                  <a:srgbClr val="7C1D2E"/>
+                </a:solidFill>
+                <a:latin typeface="Calibri"/>
+              </a:rPr>
+              <a:t>RESEARCH PROPOSAL  ·  Thank you</a:t>
+            </a:r>
+          </a:p>
+        </p:txBody>
+      </p:sp>
+      <p:sp>
+        <p:nvSpPr>
+          <p:cNvPr id="10" name="TextBox 9"/>
+          <p:cNvSpPr txBox="1"/>
+          <p:nvPr/>
+        </p:nvSpPr>
+        <p:spPr>
+          <a:xfrm>
+            <a:off x="365760" y="1024128"/>
+            <a:ext cx="11430000" cy="502920"/>
+          </a:xfrm>
+          <a:prstGeom prst="rect">
+            <a:avLst/>
+          </a:prstGeom>
+          <a:noFill/>
+        </p:spPr>
+        <p:txBody>
+          <a:bodyPr wrap="square">
+            <a:spAutoFit/>
+          </a:bodyPr>
+          <a:lstStyle/>
+          <a:p>
+            <a:pPr algn="l"/>
+            <a:r>
+              <a:rPr sz="2200" b="1">
+                <a:solidFill>
+                  <a:srgbClr val="1A1214"/>
+                </a:solidFill>
+                <a:latin typeface="Calibri"/>
+              </a:rPr>
+              <a:t>Thank you</a:t>
+            </a:r>
+          </a:p>
+        </p:txBody>
+      </p:sp>
+      <p:sp>
+        <p:nvSpPr>
+          <p:cNvPr id="11" name="TextBox 10"/>
+          <p:cNvSpPr txBox="1"/>
+          <p:nvPr/>
+        </p:nvSpPr>
+        <p:spPr>
+          <a:xfrm>
+            <a:off x="365760" y="1572768"/>
+            <a:ext cx="11430000" cy="640080"/>
+          </a:xfrm>
+          <a:prstGeom prst="rect">
+            <a:avLst/>
+          </a:prstGeom>
+          <a:noFill/>
+        </p:spPr>
+        <p:txBody>
+          <a:bodyPr wrap="square">
+            <a:spAutoFit/>
+          </a:bodyPr>
+          <a:lstStyle/>
+          <a:p>
+            <a:pPr algn="l"/>
+            <a:r>
+              <a:rPr sz="1400" b="0">
+                <a:solidFill>
+                  <a:srgbClr val="5C4A4E"/>
+                </a:solidFill>
+                <a:latin typeface="Calibri"/>
+              </a:rPr>
+              <a:t>Adaptive Context Reasoning System — a research programme, not a performance number.</a:t>
+            </a:r>
+          </a:p>
+        </p:txBody>
+      </p:sp>
+      <p:sp>
+        <p:nvSpPr>
+          <p:cNvPr id="12" name="TextBox 11"/>
+          <p:cNvSpPr txBox="1"/>
+          <p:nvPr/>
+        </p:nvSpPr>
+        <p:spPr>
+          <a:xfrm>
+            <a:off x="365760" y="2212848"/>
+            <a:ext cx="11430000" cy="3977639"/>
+          </a:xfrm>
+          <a:prstGeom prst="rect">
+            <a:avLst/>
+          </a:prstGeom>
+          <a:noFill/>
+        </p:spPr>
+        <p:txBody>
+          <a:bodyPr wrap="square">
+            <a:spAutoFit/>
+          </a:bodyPr>
+          <a:lstStyle/>
+          <a:p>
+            <a:pPr>
+              <a:spcAft>
+                <a:spcPts val="600"/>
+              </a:spcAft>
+              <a:buFont typeface="Arial"/>
+              <a:buChar char="•"/>
+            </a:pPr>
+            <a:r>
+              <a:rPr sz="1300">
+                <a:solidFill>
+                  <a:srgbClr val="1A1214"/>
+                </a:solidFill>
+                <a:latin typeface="Calibri"/>
+              </a:rPr>
+              <a:t>Presented By: Jenisha T</a:t>
+            </a:r>
+          </a:p>
+          <a:p>
+            <a:pPr>
+              <a:spcAft>
+                <a:spcPts val="600"/>
+              </a:spcAft>
+              <a:buFont typeface="Arial"/>
+              <a:buChar char="•"/>
+            </a:pPr>
+            <a:r>
+              <a:rPr sz="1300">
+                <a:solidFill>
+                  <a:srgbClr val="1A1214"/>
+                </a:solidFill>
+                <a:latin typeface="Calibri"/>
+              </a:rPr>
+              <a:t>(Reg. No. 24ETRP720001)</a:t>
+            </a:r>
+          </a:p>
+          <a:p>
+            <a:pPr>
+              <a:spcAft>
+                <a:spcPts val="600"/>
+              </a:spcAft>
+              <a:buFont typeface="Arial"/>
+              <a:buChar char="•"/>
+            </a:pPr>
+            <a:r>
+              <a:rPr sz="1300">
+                <a:solidFill>
+                  <a:srgbClr val="1A1214"/>
+                </a:solidFill>
+                <a:latin typeface="Calibri"/>
+              </a:rPr>
+              <a:t>Supervisor: Dr. Jyothi A P</a:t>
+            </a:r>
+          </a:p>
+          <a:p>
+            <a:pPr>
+              <a:spcAft>
+                <a:spcPts val="600"/>
+              </a:spcAft>
+              <a:buFont typeface="Arial"/>
+              <a:buChar char="•"/>
+            </a:pPr>
+            <a:r>
+              <a:rPr sz="1300">
+                <a:solidFill>
+                  <a:srgbClr val="1A1214"/>
+                </a:solidFill>
+                <a:latin typeface="Calibri"/>
+              </a:rPr>
+              <a:t>Department of Computer Science and Engineering</a:t>
+            </a:r>
+          </a:p>
+          <a:p>
+            <a:pPr>
+              <a:spcAft>
+                <a:spcPts val="600"/>
+              </a:spcAft>
+              <a:buFont typeface="Arial"/>
+              <a:buChar char="•"/>
+            </a:pPr>
+            <a:r>
+              <a:rPr sz="1300">
+                <a:solidFill>
+                  <a:srgbClr val="1A1214"/>
+                </a:solidFill>
+                <a:latin typeface="Calibri"/>
+              </a:rPr>
+              <a:t>Faculty of Engineering and Technology, MSRUAS</a:t>
+            </a:r>
+          </a:p>
+          <a:p>
+            <a:pPr>
+              <a:spcAft>
+                <a:spcPts val="600"/>
+              </a:spcAft>
+              <a:buFont typeface="Arial"/>
+              <a:buChar char="•"/>
+            </a:pPr>
+            <a:r>
+              <a:rPr sz="1300">
+                <a:solidFill>
+                  <a:srgbClr val="1A1214"/>
+                </a:solidFill>
+                <a:latin typeface="Calibri"/>
+              </a:rPr>
+              <a:t>jenisha.t@msruas.ac.in</a:t>
+            </a:r>
+          </a:p>
+        </p:txBody>
+      </p:sp>
+      <p:sp>
+        <p:nvSpPr>
+          <p:cNvPr id="4029" name="Automatic Date 29"/>
+          <p:cNvSpPr txBox="1"/>
+          <p:nvPr/>
+        </p:nvSpPr>
+        <p:spPr>
+          <a:xfrm>
+            <a:off x="255016" y="6565900"/>
+            <a:ext cx="3108960" cy="255016"/>
+          </a:xfrm>
+          <a:prstGeom prst="rect">
+            <a:avLst/>
+          </a:prstGeom>
+          <a:noFill/>
+        </p:spPr>
+        <p:txBody>
+          <a:bodyPr wrap="none" lIns="0" tIns="0" rIns="0" bIns="0" anchor="ctr"/>
+          <a:lstStyle/>
+          <a:p>
+            <a:pPr algn="l"/>
+            <a:fld id="{b09ad385-af60-43f0-9156-1f204ce994d0}" type="datetime3">
+              <a:rPr lang="en-GB" sz="1000" dirty="0">
+                <a:solidFill>
+                  <a:srgbClr val="C4A35A"/>
+                </a:solidFill>
+                <a:latin typeface="Calibri"/>
+              </a:rPr>
+              <a:t>7 September 2026</a:t>
+            </a:fld>
+            <a:endParaRPr lang="en-GB" sz="1000"/>
+          </a:p>
+        </p:txBody>
+      </p:sp>
+      <p:sp>
+        <p:nvSpPr>
+          <p:cNvPr id="5029" name="Automatic Slide Number 29"/>
+          <p:cNvSpPr txBox="1"/>
+          <p:nvPr/>
+        </p:nvSpPr>
+        <p:spPr>
+          <a:xfrm>
+            <a:off x="9601200" y="6565900"/>
+            <a:ext cx="2286000" cy="255016"/>
+          </a:xfrm>
+          <a:prstGeom prst="rect">
+            <a:avLst/>
+          </a:prstGeom>
+          <a:noFill/>
+        </p:spPr>
+        <p:txBody>
+          <a:bodyPr wrap="none" lIns="0" tIns="0" rIns="0" bIns="0" anchor="ctr"/>
+          <a:lstStyle/>
+          <a:p>
+            <a:pPr algn="r"/>
+            <a:fld id="{7732671a-b82b-4df5-bb6e-0afebe3b34c3}" type="slidenum">
+              <a:rPr lang="en-GB" sz="1000" dirty="0">
+                <a:solidFill>
+                  <a:srgbClr val="C4A35A"/>
+                </a:solidFill>
+                <a:latin typeface="Calibri"/>
+              </a:rPr>
+              <a:t>29</a:t>
+            </a:fld>
+            <a:r>
+              <a:rPr lang="en-GB" sz="1000">
+                <a:solidFill>
+                  <a:srgbClr val="C4A35A"/>
+                </a:solidFill>
+                <a:latin typeface="Calibri"/>
+              </a:rPr>
+              <a:t> / 29</a:t>
             </a:r>
             <a:endParaRPr lang="en-GB" sz="1000"/>
           </a:p>
@@ -18007,7 +20125,7 @@
                 </a:solidFill>
                 <a:latin typeface="Calibri"/>
               </a:rPr>
-              <a:t>Nine required sections. Research Methodology is expanded for each objective (O1 SATR, O2 APRR, O3 MNCD, O4 FCNP) plus the integrated SATR → APRR → MNCD → FCNP loop. Objective order is SATR → APRR → MNCD → FCNP (not SMART).</a:t>
+              <a:t>Nine required sections. Research Methodology is expanded for each objective (O1 SATR, O2 APRR, O3 MNCD, O4 FCNP), the integrated loop, the exact repository formulas, and two worked traces (ToolBench-schema ranking; live data.gov.in). Objective order is SATR → APRR → MNCD → FCNP (not SMART).</a:t>
             </a:r>
           </a:p>
         </p:txBody>
@@ -18282,6 +20400,60 @@
                 </a:solidFill>
                 <a:latin typeface="Calibri"/>
               </a:rPr>
+              <a:t>08f   Methodology — implementation formulas</a:t>
+            </a:r>
+          </a:p>
+          <a:p>
+            <a:pPr>
+              <a:spcAft>
+                <a:spcPts val="600"/>
+              </a:spcAft>
+              <a:buFont typeface="Arial"/>
+              <a:buChar char="•"/>
+            </a:pPr>
+            <a:r>
+              <a:rPr sz="1400">
+                <a:solidFill>
+                  <a:srgbClr val="1A1214"/>
+                </a:solidFill>
+                <a:latin typeface="Calibri"/>
+              </a:rPr>
+              <a:t>08g   Methodology — ToolBench walkthrough</a:t>
+            </a:r>
+          </a:p>
+          <a:p>
+            <a:pPr>
+              <a:spcAft>
+                <a:spcPts val="600"/>
+              </a:spcAft>
+              <a:buFont typeface="Arial"/>
+              <a:buChar char="•"/>
+            </a:pPr>
+            <a:r>
+              <a:rPr sz="1400">
+                <a:solidFill>
+                  <a:srgbClr val="1A1214"/>
+                </a:solidFill>
+                <a:latin typeface="Calibri"/>
+              </a:rPr>
+              <a:t>08h   Methodology — data.gov.in walkthrough</a:t>
+            </a:r>
+          </a:p>
+          <a:p>
+            <a:pPr>
+              <a:spcAft>
+                <a:spcPts val="600"/>
+              </a:spcAft>
+              <a:buFont typeface="Arial"/>
+              <a:buChar char="•"/>
+            </a:pPr>
+            <a:r>
+              <a:rPr sz="1400">
+                <a:solidFill>
+                  <a:srgbClr val="1A1214"/>
+                </a:solidFill>
+                <a:latin typeface="Calibri"/>
+              </a:rPr>
               <a:t>09   Conclusion</a:t>
             </a:r>
           </a:p>
@@ -18308,7 +20480,7 @@
           <a:lstStyle/>
           <a:p>
             <a:pPr algn="l"/>
-            <a:fld id="{7a1c0f1f-15a0-45f3-86d8-cbb2239fa28a}" type="datetime3">
+            <a:fld id="{223d533e-fcb4-4588-9325-65460c2034f3}" type="datetime3">
               <a:rPr lang="en-GB" sz="1000" dirty="0">
                 <a:solidFill>
                   <a:srgbClr val="C4A35A"/>
@@ -18342,7 +20514,7 @@
           <a:lstStyle/>
           <a:p>
             <a:pPr algn="r"/>
-            <a:fld id="{f18eea57-c34d-4050-9968-f266c52e60e4}" type="slidenum">
+            <a:fld id="{7db883b2-5e65-4d0a-9577-685629fc0312}" type="slidenum">
               <a:rPr lang="en-GB" sz="1000" dirty="0">
                 <a:solidFill>
                   <a:srgbClr val="C4A35A"/>
@@ -18358,7 +20530,7 @@
                 </a:solidFill>
                 <a:latin typeface="Calibri"/>
               </a:rPr>
-              <a:t> / 26</a:t>
+              <a:t> / 29</a:t>
             </a:r>
             <a:endParaRPr lang="en-GB" sz="1000"/>
           </a:p>
@@ -18881,7 +21053,7 @@
           <a:lstStyle/>
           <a:p>
             <a:pPr algn="l"/>
-            <a:fld id="{978fd5fd-074f-4174-bdfb-3d035a3d6a0c}" type="datetime3">
+            <a:fld id="{9620dd0e-9894-4538-9932-b75ff274520f}" type="datetime3">
               <a:rPr lang="en-GB" sz="1000" dirty="0">
                 <a:solidFill>
                   <a:srgbClr val="C4A35A"/>
@@ -18915,7 +21087,7 @@
           <a:lstStyle/>
           <a:p>
             <a:pPr algn="r"/>
-            <a:fld id="{44ad8e5d-1b68-40c1-b0e3-9fcc9df45212}" type="slidenum">
+            <a:fld id="{5863f060-9947-48c4-bafc-e68bb0e01203}" type="slidenum">
               <a:rPr lang="en-GB" sz="1000" dirty="0">
                 <a:solidFill>
                   <a:srgbClr val="C4A35A"/>
@@ -18931,7 +21103,7 @@
                 </a:solidFill>
                 <a:latin typeface="Calibri"/>
               </a:rPr>
-              <a:t> / 26</a:t>
+              <a:t> / 29</a:t>
             </a:r>
             <a:endParaRPr lang="en-GB" sz="1000"/>
           </a:p>
@@ -19472,7 +21644,7 @@
           <a:lstStyle/>
           <a:p>
             <a:pPr algn="l"/>
-            <a:fld id="{f6be0919-ca93-432b-af91-fd18f0d8fb7b}" type="datetime3">
+            <a:fld id="{64aedd5c-30a7-43d8-9988-d66312523c97}" type="datetime3">
               <a:rPr lang="en-GB" sz="1000" dirty="0">
                 <a:solidFill>
                   <a:srgbClr val="C4A35A"/>
@@ -19506,7 +21678,7 @@
           <a:lstStyle/>
           <a:p>
             <a:pPr algn="r"/>
-            <a:fld id="{be3fd8e2-1901-426f-b25b-d1d71de12b06}" type="slidenum">
+            <a:fld id="{1cc698ae-86b1-4454-9fb2-7fc6c9a6cdde}" type="slidenum">
               <a:rPr lang="en-GB" sz="1000" dirty="0">
                 <a:solidFill>
                   <a:srgbClr val="C4A35A"/>
@@ -19522,7 +21694,7 @@
                 </a:solidFill>
                 <a:latin typeface="Calibri"/>
               </a:rPr>
-              <a:t> / 26</a:t>
+              <a:t> / 29</a:t>
             </a:r>
             <a:endParaRPr lang="en-GB" sz="1000"/>
           </a:p>
@@ -20045,7 +22217,7 @@
           <a:lstStyle/>
           <a:p>
             <a:pPr algn="l"/>
-            <a:fld id="{fee9b8ef-1d03-415a-b117-8339c0e381a8}" type="datetime3">
+            <a:fld id="{a3e7f3a8-432e-455d-a4a7-ed4792f841e5}" type="datetime3">
               <a:rPr lang="en-GB" sz="1000" dirty="0">
                 <a:solidFill>
                   <a:srgbClr val="C4A35A"/>
@@ -20079,7 +22251,7 @@
           <a:lstStyle/>
           <a:p>
             <a:pPr algn="r"/>
-            <a:fld id="{b67c7307-2bad-44a7-be22-de0bc84f4643}" type="slidenum">
+            <a:fld id="{949733b5-734e-48ad-ab4e-dcce487b897e}" type="slidenum">
               <a:rPr lang="en-GB" sz="1000" dirty="0">
                 <a:solidFill>
                   <a:srgbClr val="C4A35A"/>
@@ -20095,7 +22267,7 @@
                 </a:solidFill>
                 <a:latin typeface="Calibri"/>
               </a:rPr>
-              <a:t> / 26</a:t>
+              <a:t> / 29</a:t>
             </a:r>
             <a:endParaRPr lang="en-GB" sz="1000"/>
           </a:p>
@@ -20958,7 +23130,7 @@
           <a:lstStyle/>
           <a:p>
             <a:pPr algn="l"/>
-            <a:fld id="{c417e24d-d11b-46b4-8226-d6948ec6242b}" type="datetime3">
+            <a:fld id="{e4e8b7a3-cf70-4e74-87b1-1232394058e4}" type="datetime3">
               <a:rPr lang="en-GB" sz="1000" dirty="0">
                 <a:solidFill>
                   <a:srgbClr val="C4A35A"/>
@@ -20992,7 +23164,7 @@
           <a:lstStyle/>
           <a:p>
             <a:pPr algn="r"/>
-            <a:fld id="{f92abb12-637b-46e2-a9fd-50bf3e903cb5}" type="slidenum">
+            <a:fld id="{73d42dcb-cd8b-4fe6-bd23-3cacbb0b4035}" type="slidenum">
               <a:rPr lang="en-GB" sz="1000" dirty="0">
                 <a:solidFill>
                   <a:srgbClr val="C4A35A"/>
@@ -21008,7 +23180,7 @@
                 </a:solidFill>
                 <a:latin typeface="Calibri"/>
               </a:rPr>
-              <a:t> / 26</a:t>
+              <a:t> / 29</a:t>
             </a:r>
             <a:endParaRPr lang="en-GB" sz="1000"/>
           </a:p>
@@ -21584,7 +23756,7 @@
           <a:lstStyle/>
           <a:p>
             <a:pPr algn="l"/>
-            <a:fld id="{5c06a2dc-ae4a-4828-9ca0-4d56a32ccfe1}" type="datetime3">
+            <a:fld id="{b5fe9bf3-f919-4574-8479-076138fc083e}" type="datetime3">
               <a:rPr lang="en-GB" sz="1000" dirty="0">
                 <a:solidFill>
                   <a:srgbClr val="C4A35A"/>
@@ -21618,7 +23790,7 @@
           <a:lstStyle/>
           <a:p>
             <a:pPr algn="r"/>
-            <a:fld id="{e7bc000f-3f53-4707-99d3-dacc62bc1248}" type="slidenum">
+            <a:fld id="{a4b3f19e-b0eb-404b-8cf5-e2af2088801b}" type="slidenum">
               <a:rPr lang="en-GB" sz="1000" dirty="0">
                 <a:solidFill>
                   <a:srgbClr val="C4A35A"/>
@@ -21634,7 +23806,7 @@
                 </a:solidFill>
                 <a:latin typeface="Calibri"/>
               </a:rPr>
-              <a:t> / 26</a:t>
+              <a:t> / 29</a:t>
             </a:r>
             <a:endParaRPr lang="en-GB" sz="1000"/>
           </a:p>
@@ -22175,7 +24347,7 @@
           <a:lstStyle/>
           <a:p>
             <a:pPr algn="l"/>
-            <a:fld id="{96bb9a69-5f70-4d74-a9f2-c8dcdd08c03b}" type="datetime3">
+            <a:fld id="{a3e62801-1a5f-4f1a-a6f1-1aee747ea848}" type="datetime3">
               <a:rPr lang="en-GB" sz="1000" dirty="0">
                 <a:solidFill>
                   <a:srgbClr val="C4A35A"/>
@@ -22209,7 +24381,7 @@
           <a:lstStyle/>
           <a:p>
             <a:pPr algn="r"/>
-            <a:fld id="{16f4da2f-6071-4dd0-b42c-2ca3c721e19a}" type="slidenum">
+            <a:fld id="{12cdba31-4ff3-4cd0-bc61-2705891444f4}" type="slidenum">
               <a:rPr lang="en-GB" sz="1000" dirty="0">
                 <a:solidFill>
                   <a:srgbClr val="C4A35A"/>
@@ -22225,7 +24397,7 @@
                 </a:solidFill>
                 <a:latin typeface="Calibri"/>
               </a:rPr>
-              <a:t> / 26</a:t>
+              <a:t> / 29</a:t>
             </a:r>
             <a:endParaRPr lang="en-GB" sz="1000"/>
           </a:p>

</xml_diff>